<commit_message>
Adiciona documentação de trabalhos relacionados e apresentação PPTX padrão IFBA
- Documento markdown com revisão de 14 trabalhos acadêmicos e da indústria
- Apresentação PowerPoint (17 slides) no padrão visual do IFBA
- Correções de acentuação em português e dados do discente/orientador

Co-Authored-By: Claude Opus 4.6 <noreply@anthropic.com>
</commit_message>
<xml_diff>
--- a/docs/trabalhos-relacionados.pptx
+++ b/docs/trabalhos-relacionados.pptx
@@ -3100,7 +3100,7 @@
     <p:bg>
       <p:bgPr>
         <a:solidFill>
-          <a:srgbClr val="0D1B2A"/>
+          <a:srgbClr val="FFFFFF"/>
         </a:solidFill>
         <a:effectLst/>
       </p:bgPr>
@@ -3121,13 +3121,13 @@
         <p:spPr>
           <a:xfrm>
             <a:off x="0" y="0"/>
-            <a:ext cx="137160" cy="6858000"/>
+            <a:ext cx="12191695" cy="1097280"/>
           </a:xfrm>
           <a:prstGeom prst="rect">
             <a:avLst/>
           </a:prstGeom>
           <a:solidFill>
-            <a:srgbClr val="007ACC"/>
+            <a:srgbClr val="2F9E41"/>
           </a:solidFill>
           <a:ln>
             <a:noFill/>
@@ -3163,14 +3163,14 @@
         </p:nvSpPr>
         <p:spPr>
           <a:xfrm>
-            <a:off x="0" y="6492240"/>
-            <a:ext cx="12191695" cy="54864"/>
+            <a:off x="0" y="1097280"/>
+            <a:ext cx="12191695" cy="73152"/>
           </a:xfrm>
           <a:prstGeom prst="rect">
             <a:avLst/>
           </a:prstGeom>
           <a:solidFill>
-            <a:srgbClr val="416D9F"/>
+            <a:srgbClr val="CD191E"/>
           </a:solidFill>
           <a:ln>
             <a:noFill/>
@@ -3206,8 +3206,8 @@
         </p:nvSpPr>
         <p:spPr>
           <a:xfrm>
-            <a:off x="1371600" y="1371600"/>
-            <a:ext cx="9144000" cy="914400"/>
+            <a:off x="1371600" y="137160"/>
+            <a:ext cx="9144000" cy="411480"/>
           </a:xfrm>
           <a:prstGeom prst="rect">
             <a:avLst/>
@@ -3221,7 +3221,7 @@
           <a:lstStyle/>
           <a:p>
             <a:pPr algn="ctr">
-              <a:defRPr sz="3600" b="1">
+              <a:defRPr sz="1600" b="1">
                 <a:solidFill>
                   <a:srgbClr val="FFFFFF"/>
                 </a:solidFill>
@@ -3229,7 +3229,7 @@
               </a:defRPr>
             </a:pPr>
             <a:r>
-              <a:t>TRABALHOS RELACIONADOS E ESTADO DA ARTE</a:t>
+              <a:t>INSTITUTO FEDERAL DE EDUCAÇÃO, CIÊNCIA E TECNOLOGIA DA BAHIA</a:t>
             </a:r>
           </a:p>
         </p:txBody>
@@ -3242,8 +3242,8 @@
         </p:nvSpPr>
         <p:spPr>
           <a:xfrm>
-            <a:off x="1371600" y="2286000"/>
-            <a:ext cx="9144000" cy="731520"/>
+            <a:off x="1371600" y="548640"/>
+            <a:ext cx="9144000" cy="365760"/>
           </a:xfrm>
           <a:prstGeom prst="rect">
             <a:avLst/>
@@ -3257,15 +3257,87 @@
           <a:lstStyle/>
           <a:p>
             <a:pPr algn="ctr">
-              <a:defRPr sz="2000" b="0">
-                <a:solidFill>
-                  <a:srgbClr val="AACCEE"/>
+              <a:defRPr sz="2400" b="1">
+                <a:solidFill>
+                  <a:srgbClr val="FFFFFF"/>
                 </a:solidFill>
                 <a:latin typeface="Segoe UI"/>
               </a:defRPr>
             </a:pPr>
             <a:r>
-              <a:t>Autenticacao Adaptativa com Inteligencia Artificial,</a:t>
+              <a:t>IFBA</a:t>
+            </a:r>
+          </a:p>
+        </p:txBody>
+      </p:sp>
+      <p:sp>
+        <p:nvSpPr>
+          <p:cNvPr id="6" name="TextBox 5"/>
+          <p:cNvSpPr txBox="1"/>
+          <p:nvPr/>
+        </p:nvSpPr>
+        <p:spPr>
+          <a:xfrm>
+            <a:off x="1097280" y="1645920"/>
+            <a:ext cx="9966960" cy="1097280"/>
+          </a:xfrm>
+          <a:prstGeom prst="rect">
+            <a:avLst/>
+          </a:prstGeom>
+          <a:noFill/>
+        </p:spPr>
+        <p:txBody>
+          <a:bodyPr wrap="square">
+            <a:spAutoFit/>
+          </a:bodyPr>
+          <a:lstStyle/>
+          <a:p>
+            <a:pPr algn="ctr">
+              <a:defRPr sz="3200" b="1">
+                <a:solidFill>
+                  <a:srgbClr val="1A6B2A"/>
+                </a:solidFill>
+                <a:latin typeface="Segoe UI"/>
+              </a:defRPr>
+            </a:pPr>
+            <a:r>
+              <a:t>TRABALHOS RELACIONADOS E ESTADO DA ARTE</a:t>
+            </a:r>
+          </a:p>
+        </p:txBody>
+      </p:sp>
+      <p:sp>
+        <p:nvSpPr>
+          <p:cNvPr id="7" name="TextBox 6"/>
+          <p:cNvSpPr txBox="1"/>
+          <p:nvPr/>
+        </p:nvSpPr>
+        <p:spPr>
+          <a:xfrm>
+            <a:off x="1371600" y="2743200"/>
+            <a:ext cx="9144000" cy="731520"/>
+          </a:xfrm>
+          <a:prstGeom prst="rect">
+            <a:avLst/>
+          </a:prstGeom>
+          <a:noFill/>
+        </p:spPr>
+        <p:txBody>
+          <a:bodyPr wrap="square">
+            <a:spAutoFit/>
+          </a:bodyPr>
+          <a:lstStyle/>
+          <a:p>
+            <a:pPr algn="ctr">
+              <a:defRPr sz="1800" b="0">
+                <a:solidFill>
+                  <a:srgbClr val="4A4A4A"/>
+                </a:solidFill>
+                <a:latin typeface="Segoe UI"/>
+              </a:defRPr>
+            </a:pPr>
+            <a:r>
+              <a:t>Autenticação Adaptativa com Inteligência Artificial,</a:t>
             </a:r>
             <a:br/>
             <a:r>
@@ -3276,20 +3348,20 @@
       </p:sp>
       <p:sp>
         <p:nvSpPr>
-          <p:cNvPr id="6" name="Rectangle 5"/>
+          <p:cNvPr id="8" name="Rectangle 7"/>
           <p:cNvSpPr/>
           <p:nvPr/>
         </p:nvSpPr>
         <p:spPr>
           <a:xfrm>
-            <a:off x="5029200" y="3200400"/>
-            <a:ext cx="2103120" cy="36576"/>
+            <a:off x="4572000" y="3566160"/>
+            <a:ext cx="3017520" cy="36576"/>
           </a:xfrm>
           <a:prstGeom prst="rect">
             <a:avLst/>
           </a:prstGeom>
           <a:solidFill>
-            <a:srgbClr val="007ACC"/>
+            <a:srgbClr val="2F9E41"/>
           </a:solidFill>
           <a:ln>
             <a:noFill/>
@@ -3319,13 +3391,13 @@
       </p:sp>
       <p:sp>
         <p:nvSpPr>
-          <p:cNvPr id="7" name="TextBox 6"/>
+          <p:cNvPr id="9" name="TextBox 8"/>
           <p:cNvSpPr txBox="1"/>
           <p:nvPr/>
         </p:nvSpPr>
         <p:spPr>
           <a:xfrm>
-            <a:off x="1371600" y="3657600"/>
+            <a:off x="1371600" y="3840480"/>
             <a:ext cx="9144000" cy="457200"/>
           </a:xfrm>
           <a:prstGeom prst="rect">
@@ -3340,29 +3412,29 @@
           <a:lstStyle/>
           <a:p>
             <a:pPr algn="ctr">
-              <a:defRPr sz="1800" b="0">
-                <a:solidFill>
-                  <a:srgbClr val="88AACC"/>
+              <a:defRPr sz="1600" b="1">
+                <a:solidFill>
+                  <a:srgbClr val="1A6B2A"/>
                 </a:solidFill>
                 <a:latin typeface="Segoe UI"/>
               </a:defRPr>
             </a:pPr>
             <a:r>
-              <a:t>Sistema Autonomo de Autenticacao Inteligente</a:t>
-            </a:r>
-          </a:p>
-        </p:txBody>
-      </p:sp>
-      <p:sp>
-        <p:nvSpPr>
-          <p:cNvPr id="8" name="TextBox 7"/>
+              <a:t>Sistema Autônomo de Autenticação Inteligente</a:t>
+            </a:r>
+          </a:p>
+        </p:txBody>
+      </p:sp>
+      <p:sp>
+        <p:nvSpPr>
+          <p:cNvPr id="10" name="TextBox 9"/>
           <p:cNvSpPr txBox="1"/>
           <p:nvPr/>
         </p:nvSpPr>
         <p:spPr>
           <a:xfrm>
-            <a:off x="1371600" y="5029200"/>
-            <a:ext cx="9144000" cy="457200"/>
+            <a:off x="1371600" y="4754880"/>
+            <a:ext cx="9144000" cy="365760"/>
           </a:xfrm>
           <a:prstGeom prst="rect">
             <a:avLst/>
@@ -3378,13 +3450,171 @@
             <a:pPr algn="ctr">
               <a:defRPr sz="1400" b="0">
                 <a:solidFill>
-                  <a:srgbClr val="6688AA"/>
+                  <a:srgbClr val="4A4A4A"/>
                 </a:solidFill>
                 <a:latin typeface="Segoe UI"/>
               </a:defRPr>
             </a:pPr>
             <a:r>
-              <a:t>Abril 2026</a:t>
+              <a:t>Discente: João Guedes de Brito</a:t>
+            </a:r>
+          </a:p>
+        </p:txBody>
+      </p:sp>
+      <p:sp>
+        <p:nvSpPr>
+          <p:cNvPr id="11" name="TextBox 10"/>
+          <p:cNvSpPr txBox="1"/>
+          <p:nvPr/>
+        </p:nvSpPr>
+        <p:spPr>
+          <a:xfrm>
+            <a:off x="1371600" y="5120640"/>
+            <a:ext cx="9144000" cy="365760"/>
+          </a:xfrm>
+          <a:prstGeom prst="rect">
+            <a:avLst/>
+          </a:prstGeom>
+          <a:noFill/>
+        </p:spPr>
+        <p:txBody>
+          <a:bodyPr wrap="square">
+            <a:spAutoFit/>
+          </a:bodyPr>
+          <a:lstStyle/>
+          <a:p>
+            <a:pPr algn="ctr">
+              <a:defRPr sz="1400" b="0">
+                <a:solidFill>
+                  <a:srgbClr val="4A4A4A"/>
+                </a:solidFill>
+                <a:latin typeface="Segoe UI"/>
+              </a:defRPr>
+            </a:pPr>
+            <a:r>
+              <a:t>Orientador: Prof. Cleber Jorge Lira de Santana</a:t>
+            </a:r>
+          </a:p>
+        </p:txBody>
+      </p:sp>
+      <p:sp>
+        <p:nvSpPr>
+          <p:cNvPr id="12" name="Rectangle 11"/>
+          <p:cNvSpPr/>
+          <p:nvPr/>
+        </p:nvSpPr>
+        <p:spPr>
+          <a:xfrm>
+            <a:off x="0" y="6217920"/>
+            <a:ext cx="12191695" cy="73152"/>
+          </a:xfrm>
+          <a:prstGeom prst="rect">
+            <a:avLst/>
+          </a:prstGeom>
+          <a:solidFill>
+            <a:srgbClr val="CD191E"/>
+          </a:solidFill>
+          <a:ln>
+            <a:noFill/>
+          </a:ln>
+        </p:spPr>
+        <p:style>
+          <a:lnRef idx="1">
+            <a:schemeClr val="accent1"/>
+          </a:lnRef>
+          <a:fillRef idx="3">
+            <a:schemeClr val="accent1"/>
+          </a:fillRef>
+          <a:effectRef idx="2">
+            <a:schemeClr val="accent1"/>
+          </a:effectRef>
+          <a:fontRef idx="minor">
+            <a:schemeClr val="lt1"/>
+          </a:fontRef>
+        </p:style>
+        <p:txBody>
+          <a:bodyPr rtlCol="0" anchor="ctr"/>
+          <a:lstStyle/>
+          <a:p>
+            <a:pPr algn="ctr"/>
+          </a:p>
+        </p:txBody>
+      </p:sp>
+      <p:sp>
+        <p:nvSpPr>
+          <p:cNvPr id="13" name="Rectangle 12"/>
+          <p:cNvSpPr/>
+          <p:nvPr/>
+        </p:nvSpPr>
+        <p:spPr>
+          <a:xfrm>
+            <a:off x="0" y="6291072"/>
+            <a:ext cx="12191695" cy="566928"/>
+          </a:xfrm>
+          <a:prstGeom prst="rect">
+            <a:avLst/>
+          </a:prstGeom>
+          <a:solidFill>
+            <a:srgbClr val="2F9E41"/>
+          </a:solidFill>
+          <a:ln>
+            <a:noFill/>
+          </a:ln>
+        </p:spPr>
+        <p:style>
+          <a:lnRef idx="1">
+            <a:schemeClr val="accent1"/>
+          </a:lnRef>
+          <a:fillRef idx="3">
+            <a:schemeClr val="accent1"/>
+          </a:fillRef>
+          <a:effectRef idx="2">
+            <a:schemeClr val="accent1"/>
+          </a:effectRef>
+          <a:fontRef idx="minor">
+            <a:schemeClr val="lt1"/>
+          </a:fontRef>
+        </p:style>
+        <p:txBody>
+          <a:bodyPr rtlCol="0" anchor="ctr"/>
+          <a:lstStyle/>
+          <a:p>
+            <a:pPr algn="ctr"/>
+          </a:p>
+        </p:txBody>
+      </p:sp>
+      <p:sp>
+        <p:nvSpPr>
+          <p:cNvPr id="14" name="TextBox 13"/>
+          <p:cNvSpPr txBox="1"/>
+          <p:nvPr/>
+        </p:nvSpPr>
+        <p:spPr>
+          <a:xfrm>
+            <a:off x="1371600" y="6355080"/>
+            <a:ext cx="9144000" cy="365760"/>
+          </a:xfrm>
+          <a:prstGeom prst="rect">
+            <a:avLst/>
+          </a:prstGeom>
+          <a:noFill/>
+        </p:spPr>
+        <p:txBody>
+          <a:bodyPr wrap="square">
+            <a:spAutoFit/>
+          </a:bodyPr>
+          <a:lstStyle/>
+          <a:p>
+            <a:pPr algn="ctr">
+              <a:defRPr sz="1300" b="0">
+                <a:solidFill>
+                  <a:srgbClr val="FFFFFF"/>
+                </a:solidFill>
+                <a:latin typeface="Segoe UI"/>
+              </a:defRPr>
+            </a:pPr>
+            <a:r>
+              <a:t>Salvador - BA | Abril 2026</a:t>
             </a:r>
           </a:p>
         </p:txBody>
@@ -3430,7 +3660,7 @@
             <a:avLst/>
           </a:prstGeom>
           <a:solidFill>
-            <a:srgbClr val="0D1B2A"/>
+            <a:srgbClr val="1A6B2A"/>
           </a:solidFill>
           <a:ln>
             <a:noFill/>
@@ -3519,7 +3749,7 @@
             <a:pPr algn="l">
               <a:defRPr sz="1400" b="0">
                 <a:solidFill>
-                  <a:srgbClr val="AACCEE"/>
+                  <a:srgbClr val="B0E0B0"/>
                 </a:solidFill>
                 <a:latin typeface="Segoe UI"/>
               </a:defRPr>
@@ -3545,7 +3775,7 @@
             <a:avLst/>
           </a:prstGeom>
           <a:solidFill>
-            <a:srgbClr val="007ACC"/>
+            <a:srgbClr val="CD191E"/>
           </a:solidFill>
           <a:ln>
             <a:noFill/>
@@ -3643,13 +3873,13 @@
             <a:pPr algn="l">
               <a:defRPr sz="1400" b="1">
                 <a:solidFill>
-                  <a:srgbClr val="007ACC"/>
+                  <a:srgbClr val="2F9E41"/>
                 </a:solidFill>
                 <a:latin typeface="Segoe UI"/>
               </a:defRPr>
             </a:pPr>
             <a:r>
-              <a:t>Descricao do Trabalho</a:t>
+              <a:t>Descrição do Trabalho</a:t>
             </a:r>
           </a:p>
         </p:txBody>
@@ -3685,7 +3915,7 @@
               </a:defRPr>
             </a:pPr>
             <a:r>
-              <a:t>O MDPI propoe mecanismo generico de audit trail com smart contracts. Harpocrates implementa logs imutaveis com preservacao de privacidade sobre Hyperledger Fabric em Amazon EC2, combinando tecnicas criptograficas com imutabilidade blockchain.</a:t>
+              <a:t>O MDPI propõe mecanismo genérico de audit trail com smart contracts. Harpocrates implementa logs imutáveis com preservação de privacidade sobre Hyperledger Fabric em Amazon EC2, combinando técnicas criptográficas com imutabilidade blockchain.</a:t>
             </a:r>
           </a:p>
         </p:txBody>
@@ -3760,13 +3990,13 @@
             <a:pPr algn="l">
               <a:defRPr sz="1400" b="1">
                 <a:solidFill>
-                  <a:srgbClr val="27AE60"/>
+                  <a:srgbClr val="2F9E41"/>
                 </a:solidFill>
                 <a:latin typeface="Segoe UI"/>
               </a:defRPr>
             </a:pPr>
             <a:r>
-              <a:t>Comparacao com a Proposta</a:t>
+              <a:t>Comparação com a Proposta</a:t>
             </a:r>
           </a:p>
         </p:txBody>
@@ -3802,7 +4032,7 @@
               </a:defRPr>
             </a:pPr>
             <a:r>
-              <a:t>O sistema proposto registra especificamente eventos de autenticacao (hash, tipo de evento, ID hasheado SHA-3, IP, score, decisao, timestamp) em blockchain dual (Hyperledger Fabric + Ethereum). Opera em modo simulacao para dev e redes reais em producao — flexibilidade nao presente nos comparados.</a:t>
+              <a:t>O sistema proposto registra especificamente eventos de autenticação (hash, tipo de evento, ID hasheado SHA-3, IP, score, decisão, timestamp) em blockchain dual (Hyperledger Fabric + Ethereum). Opera em modo simulação para dev e redes reais em produção — flexibilidade não presente nos comparados.</a:t>
             </a:r>
           </a:p>
         </p:txBody>
@@ -3848,7 +4078,7 @@
             <a:avLst/>
           </a:prstGeom>
           <a:solidFill>
-            <a:srgbClr val="0D1B2A"/>
+            <a:srgbClr val="1A6B2A"/>
           </a:solidFill>
           <a:ln>
             <a:noFill/>
@@ -3937,7 +4167,7 @@
             <a:pPr algn="l">
               <a:defRPr sz="1400" b="0">
                 <a:solidFill>
-                  <a:srgbClr val="AACCEE"/>
+                  <a:srgbClr val="B0E0B0"/>
                 </a:solidFill>
                 <a:latin typeface="Segoe UI"/>
               </a:defRPr>
@@ -3963,7 +4193,7 @@
             <a:avLst/>
           </a:prstGeom>
           <a:solidFill>
-            <a:srgbClr val="007ACC"/>
+            <a:srgbClr val="CD191E"/>
           </a:solidFill>
           <a:ln>
             <a:noFill/>
@@ -4061,13 +4291,13 @@
             <a:pPr algn="l">
               <a:defRPr sz="1400" b="1">
                 <a:solidFill>
-                  <a:srgbClr val="007ACC"/>
+                  <a:srgbClr val="2F9E41"/>
                 </a:solidFill>
                 <a:latin typeface="Segoe UI"/>
               </a:defRPr>
             </a:pPr>
             <a:r>
-              <a:t>Descricao do Trabalho</a:t>
+              <a:t>Descrição do Trabalho</a:t>
             </a:r>
           </a:p>
         </p:txBody>
@@ -4103,7 +4333,7 @@
               </a:defRPr>
             </a:pPr>
             <a:r>
-              <a:t>O trabalho ScienceDirect combina Hyperledger Fabric com OAuth 2.0 para IAM no setor de saude. O IEEE (2018) e um trabalho pioneiro de autenticacao baseada em risco com ML, classificando logins por nivel de risco com features contextuais basicas.</a:t>
+              <a:t>O trabalho ScienceDirect combina Hyperledger Fabric com OAuth 2.0 para IAM no setor de saúde. O IEEE (2018) é um trabalho pioneiro de autenticação baseada em risco com ML, classificando logins por nível de risco com features contextuais básicas.</a:t>
             </a:r>
           </a:p>
         </p:txBody>
@@ -4178,13 +4408,13 @@
             <a:pPr algn="l">
               <a:defRPr sz="1400" b="1">
                 <a:solidFill>
-                  <a:srgbClr val="27AE60"/>
+                  <a:srgbClr val="2F9E41"/>
                 </a:solidFill>
                 <a:latin typeface="Segoe UI"/>
               </a:defRPr>
             </a:pPr>
             <a:r>
-              <a:t>Comparacao com a Proposta</a:t>
+              <a:t>Comparação com a Proposta</a:t>
             </a:r>
           </a:p>
         </p:txBody>
@@ -4220,7 +4450,7 @@
               </a:defRPr>
             </a:pPr>
             <a:r>
-              <a:t>O sistema proposto substitui autenticacao estatica (OAuth) por score dinamico de IA, com 4 niveis de resposta em vez de decisao binaria. Expande o trabalho de 2018 com ensemble de 3 algoritmos, 14 features, biometria comportamental, blockchain e explicabilidade.</a:t>
+              <a:t>O sistema proposto substitui autenticação estática (OAuth) por score dinâmico de IA, com 4 níveis de resposta em vez de decisão binária. Expande o trabalho de 2018 com ensemble de 3 algoritmos, 14 features, biometria comportamental, blockchain e explicabilidade.</a:t>
             </a:r>
           </a:p>
         </p:txBody>
@@ -4266,7 +4496,7 @@
             <a:avLst/>
           </a:prstGeom>
           <a:solidFill>
-            <a:srgbClr val="0D1B2A"/>
+            <a:srgbClr val="1A6B2A"/>
           </a:solidFill>
           <a:ln>
             <a:noFill/>
@@ -4355,7 +4585,7 @@
             <a:pPr algn="l">
               <a:defRPr sz="1400" b="0">
                 <a:solidFill>
-                  <a:srgbClr val="AACCEE"/>
+                  <a:srgbClr val="B0E0B0"/>
                 </a:solidFill>
                 <a:latin typeface="Segoe UI"/>
               </a:defRPr>
@@ -4381,7 +4611,7 @@
             <a:avLst/>
           </a:prstGeom>
           <a:solidFill>
-            <a:srgbClr val="007ACC"/>
+            <a:srgbClr val="CD191E"/>
           </a:solidFill>
           <a:ln>
             <a:noFill/>
@@ -4479,13 +4709,13 @@
             <a:pPr algn="l">
               <a:defRPr sz="1400" b="1">
                 <a:solidFill>
-                  <a:srgbClr val="007ACC"/>
+                  <a:srgbClr val="2F9E41"/>
                 </a:solidFill>
                 <a:latin typeface="Segoe UI"/>
               </a:defRPr>
             </a:pPr>
             <a:r>
-              <a:t>Descricao do Trabalho</a:t>
+              <a:t>Descrição do Trabalho</a:t>
             </a:r>
           </a:p>
         </p:txBody>
@@ -4521,7 +4751,7 @@
               </a:defRPr>
             </a:pPr>
             <a:r>
-              <a:t>Trust Engine: score dinamico passwordless com TAR&gt;90% e FAR&lt;5%. Zero Trust: RL para enforcement adaptativo. XAI: revisao de SHAP/LIME para IDS. Drift Detection: LSTM+Autoencoder com KL-divergence para detectar mudancas de comportamento.</a:t>
+              <a:t>Trust Engine: score dinâmico passwordless com TAR&gt;90% e FAR&lt;5%. Zero Trust: RL para enforcement adaptativo. XAI: revisão de SHAP/LIME para IDS. Drift Detection: LSTM+Autoencoder com KL-divergence para detectar mudanças de comportamento.</a:t>
             </a:r>
           </a:p>
         </p:txBody>
@@ -4596,13 +4826,13 @@
             <a:pPr algn="l">
               <a:defRPr sz="1400" b="1">
                 <a:solidFill>
-                  <a:srgbClr val="27AE60"/>
+                  <a:srgbClr val="2F9E41"/>
                 </a:solidFill>
                 <a:latin typeface="Segoe UI"/>
               </a:defRPr>
             </a:pPr>
             <a:r>
-              <a:t>Comparacao com a Proposta</a:t>
+              <a:t>Comparação com a Proposta</a:t>
             </a:r>
           </a:p>
         </p:txBody>
@@ -4638,7 +4868,7 @@
               </a:defRPr>
             </a:pPr>
             <a:r>
-              <a:t>O sistema proposto integra TODOS esses elementos em uma unica plataforma: score de confianca (como Trust Engine), decisoes adaptativas (como Zero Trust), explicabilidade SHAP (como XAI), e deteccao de deriva (como Drift Detection) — com o diferencial de registro imutavel em blockchain de cada decisao e explicacao.</a:t>
+              <a:t>O sistema proposto integra TODOS esses elementos em uma única plataforma: score de confiança (como Trust Engine), decisões adaptativas (como Zero Trust), explicabilidade SHAP (como XAI), e detecção de deriva (como Drift Detection) — com o diferencial de registro imutável em blockchain de cada decisão e explicação.</a:t>
             </a:r>
           </a:p>
         </p:txBody>
@@ -4684,7 +4914,7 @@
             <a:avLst/>
           </a:prstGeom>
           <a:solidFill>
-            <a:srgbClr val="0D1B2A"/>
+            <a:srgbClr val="1A6B2A"/>
           </a:solidFill>
           <a:ln>
             <a:noFill/>
@@ -4743,7 +4973,7 @@
               </a:defRPr>
             </a:pPr>
             <a:r>
-              <a:t>Solucoes da Industria</a:t>
+              <a:t>Soluções da Indústria</a:t>
             </a:r>
           </a:p>
         </p:txBody>
@@ -4773,7 +5003,7 @@
             <a:pPr algn="l">
               <a:defRPr sz="1400" b="0">
                 <a:solidFill>
-                  <a:srgbClr val="AACCEE"/>
+                  <a:srgbClr val="B0E0B0"/>
                 </a:solidFill>
                 <a:latin typeface="Segoe UI"/>
               </a:defRPr>
@@ -4799,7 +5029,7 @@
             <a:avLst/>
           </a:prstGeom>
           <a:solidFill>
-            <a:srgbClr val="007ACC"/>
+            <a:srgbClr val="CD191E"/>
           </a:solidFill>
           <a:ln>
             <a:noFill/>
@@ -4897,7 +5127,7 @@
             <a:pPr algn="l">
               <a:defRPr sz="1600" b="1">
                 <a:solidFill>
-                  <a:srgbClr val="007ACC"/>
+                  <a:srgbClr val="2F9E41"/>
                 </a:solidFill>
                 <a:latin typeface="Segoe UI"/>
               </a:defRPr>
@@ -4939,7 +5169,7 @@
               </a:defRPr>
             </a:pPr>
             <a:r>
-              <a:t>Suite de prevencao de fraude com IA, biometria comportamental e inteligencia global. Analisa sinais de identidade digital e informacoes de dispositivo. Utilizado por centenas de instituicoes financeiras.</a:t>
+              <a:t>Suíte de prevenção de fraude com IA, biometria comportamental e inteligência global. Analisa sinais de identidade digital e informações de dispositivo. Utilizado por centenas de instituições financeiras.</a:t>
             </a:r>
           </a:p>
         </p:txBody>
@@ -4969,7 +5199,7 @@
             <a:pPr algn="l">
               <a:defRPr sz="1300" b="1">
                 <a:solidFill>
-                  <a:srgbClr val="27AE60"/>
+                  <a:srgbClr val="2F9E41"/>
                 </a:solidFill>
                 <a:latin typeface="Segoe UI"/>
               </a:defRPr>
@@ -5011,7 +5241,7 @@
               </a:defRPr>
             </a:pPr>
             <a:r>
-              <a:t>Trusteer e proprietario/black-box. A proposta oferece: explicabilidade SHAP, blockchain para auditoria, arquitetura aberta e reprodutivel, metricas e decisoes transparentes.</a:t>
+              <a:t>Trusteer é proprietário/black-box. A proposta oferece: explicabilidade SHAP, blockchain para auditoria, arquitetura aberta e reprodutível, métricas e decisões transparentes.</a:t>
             </a:r>
           </a:p>
         </p:txBody>
@@ -5086,7 +5316,7 @@
             <a:pPr algn="l">
               <a:defRPr sz="1600" b="1">
                 <a:solidFill>
-                  <a:srgbClr val="007ACC"/>
+                  <a:srgbClr val="2F9E41"/>
                 </a:solidFill>
                 <a:latin typeface="Segoe UI"/>
               </a:defRPr>
@@ -5128,7 +5358,7 @@
               </a:defRPr>
             </a:pPr>
             <a:r>
-              <a:t>Biometria comportamental cognitiva e fisica para prevencao de fraude. Analisa interacoes humano-dispositivo com IA. Diferencia usuarios legitimos de fraudadores. Adotado por bancos globais.</a:t>
+              <a:t>Biometria comportamental cognitiva e física para prevenção de fraude. Analisa interações humano-dispositivo com IA. Diferencia usuários legítimos de fraudadores. Adotado por bancos globais.</a:t>
             </a:r>
           </a:p>
         </p:txBody>
@@ -5158,7 +5388,7 @@
             <a:pPr algn="l">
               <a:defRPr sz="1300" b="1">
                 <a:solidFill>
-                  <a:srgbClr val="27AE60"/>
+                  <a:srgbClr val="2F9E41"/>
                 </a:solidFill>
                 <a:latin typeface="Segoe UI"/>
               </a:defRPr>
@@ -5200,7 +5430,7 @@
               </a:defRPr>
             </a:pPr>
             <a:r>
-              <a:t>BioCatch e SaaS proprietario para fraude financeira. A proposta e voltada para autenticacao web geral, com ensemble explicito de 3 algoritmos, blockchain dual, explicabilidade SHAP e deteccao de deriva.</a:t>
+              <a:t>BioCatch é SaaS proprietário para fraude financeira. A proposta é voltada para autenticação web geral, com ensemble explícito de 3 algoritmos, blockchain dual, explicabilidade SHAP e detecção de deriva.</a:t>
             </a:r>
           </a:p>
         </p:txBody>
@@ -5246,7 +5476,7 @@
             <a:avLst/>
           </a:prstGeom>
           <a:solidFill>
-            <a:srgbClr val="0D1B2A"/>
+            <a:srgbClr val="1A6B2A"/>
           </a:solidFill>
           <a:ln>
             <a:noFill/>
@@ -5305,7 +5535,7 @@
               </a:defRPr>
             </a:pPr>
             <a:r>
-              <a:t>Sintese Comparativa</a:t>
+              <a:t>Síntese Comparativa</a:t>
             </a:r>
           </a:p>
         </p:txBody>
@@ -5335,7 +5565,7 @@
             <a:pPr algn="l">
               <a:defRPr sz="1400" b="0">
                 <a:solidFill>
-                  <a:srgbClr val="AACCEE"/>
+                  <a:srgbClr val="B0E0B0"/>
                 </a:solidFill>
                 <a:latin typeface="Segoe UI"/>
               </a:defRPr>
@@ -5361,7 +5591,7 @@
             <a:avLst/>
           </a:prstGeom>
           <a:solidFill>
-            <a:srgbClr val="007ACC"/>
+            <a:srgbClr val="CD191E"/>
           </a:solidFill>
           <a:ln>
             <a:noFill/>
@@ -5428,13 +5658,13 @@
                         </a:defRPr>
                       </a:pPr>
                       <a:r>
-                        <a:t>Caracteristica</a:t>
+                        <a:t>Característica</a:t>
                       </a:r>
                     </a:p>
                   </a:txBody>
                   <a:tcPr>
                     <a:solidFill>
-                      <a:srgbClr val="0D1B2A"/>
+                      <a:srgbClr val="1A6B2A"/>
                     </a:solidFill>
                   </a:tcPr>
                 </a:tc>
@@ -5458,7 +5688,7 @@
                   </a:txBody>
                   <a:tcPr>
                     <a:solidFill>
-                      <a:srgbClr val="0D1B2A"/>
+                      <a:srgbClr val="1A6B2A"/>
                     </a:solidFill>
                   </a:tcPr>
                 </a:tc>
@@ -5482,7 +5712,7 @@
                   </a:txBody>
                   <a:tcPr>
                     <a:solidFill>
-                      <a:srgbClr val="0D1B2A"/>
+                      <a:srgbClr val="1A6B2A"/>
                     </a:solidFill>
                   </a:tcPr>
                 </a:tc>
@@ -5500,13 +5730,13 @@
                         </a:defRPr>
                       </a:pPr>
                       <a:r>
-                        <a:t>Industria</a:t>
+                        <a:t>Indústria</a:t>
                       </a:r>
                     </a:p>
                   </a:txBody>
                   <a:tcPr>
                     <a:solidFill>
-                      <a:srgbClr val="0D1B2A"/>
+                      <a:srgbClr val="1A6B2A"/>
                     </a:solidFill>
                   </a:tcPr>
                 </a:tc>
@@ -5526,7 +5756,7 @@
                         </a:defRPr>
                       </a:pPr>
                       <a:r>
-                        <a:t>Ensemble de 3 algoritmos (IF+RF+DL) com pesos configuraveis</a:t>
+                        <a:t>Ensemble de 3 algoritmos (IF+RF+DL) com pesos configuráveis</a:t>
                       </a:r>
                     </a:p>
                   </a:txBody>
@@ -5544,7 +5774,7 @@
                       <a:pPr>
                         <a:defRPr sz="1100" b="1">
                           <a:solidFill>
-                            <a:srgbClr val="27AE60"/>
+                            <a:srgbClr val="2F9E41"/>
                           </a:solidFill>
                           <a:latin typeface="Segoe UI"/>
                         </a:defRPr>
@@ -5598,7 +5828,7 @@
                         </a:defRPr>
                       </a:pPr>
                       <a:r>
-                        <a:t>Nao divulgado</a:t>
+                        <a:t>Não divulgado</a:t>
                       </a:r>
                     </a:p>
                   </a:txBody>
@@ -5624,7 +5854,7 @@
                         </a:defRPr>
                       </a:pPr>
                       <a:r>
-                        <a:t>Score de confianca com 4 niveis de decisao</a:t>
+                        <a:t>Score de confiança com 4 níveis de decisão</a:t>
                       </a:r>
                     </a:p>
                   </a:txBody>
@@ -5642,7 +5872,7 @@
                       <a:pPr>
                         <a:defRPr sz="1100" b="1">
                           <a:solidFill>
-                            <a:srgbClr val="27AE60"/>
+                            <a:srgbClr val="2F9E41"/>
                           </a:solidFill>
                           <a:latin typeface="Segoe UI"/>
                         </a:defRPr>
@@ -5672,7 +5902,7 @@
                         </a:defRPr>
                       </a:pPr>
                       <a:r>
-                        <a:t>Binario ou ternario</a:t>
+                        <a:t>Binário ou ternário</a:t>
                       </a:r>
                     </a:p>
                   </a:txBody>
@@ -5696,7 +5926,7 @@
                         </a:defRPr>
                       </a:pPr>
                       <a:r>
-                        <a:t>Nao divulgado</a:t>
+                        <a:t>Não divulgado</a:t>
                       </a:r>
                     </a:p>
                   </a:txBody>
@@ -5740,7 +5970,7 @@
                       <a:pPr>
                         <a:defRPr sz="1100" b="1">
                           <a:solidFill>
-                            <a:srgbClr val="27AE60"/>
+                            <a:srgbClr val="2F9E41"/>
                           </a:solidFill>
                           <a:latin typeface="Segoe UI"/>
                         </a:defRPr>
@@ -5794,7 +6024,7 @@
                         </a:defRPr>
                       </a:pPr>
                       <a:r>
-                        <a:t>Nao utilizado</a:t>
+                        <a:t>Não utilizado</a:t>
                       </a:r>
                     </a:p>
                   </a:txBody>
@@ -5820,7 +6050,7 @@
                         </a:defRPr>
                       </a:pPr>
                       <a:r>
-                        <a:t>Explicabilidade via SHAP para autenticacao</a:t>
+                        <a:t>Explicabilidade via SHAP para autenticação</a:t>
                       </a:r>
                     </a:p>
                   </a:txBody>
@@ -5838,7 +6068,7 @@
                       <a:pPr>
                         <a:defRPr sz="1100" b="1">
                           <a:solidFill>
-                            <a:srgbClr val="27AE60"/>
+                            <a:srgbClr val="2F9E41"/>
                           </a:solidFill>
                           <a:latin typeface="Segoe UI"/>
                         </a:defRPr>
@@ -5892,7 +6122,7 @@
                         </a:defRPr>
                       </a:pPr>
                       <a:r>
-                        <a:t>Nao disponivel</a:t>
+                        <a:t>Não disponível</a:t>
                       </a:r>
                     </a:p>
                   </a:txBody>
@@ -5918,7 +6148,7 @@
                         </a:defRPr>
                       </a:pPr>
                       <a:r>
-                        <a:t>Deteccao de deriva comportamental integrada</a:t>
+                        <a:t>Detecção de deriva comportamental integrada</a:t>
                       </a:r>
                     </a:p>
                   </a:txBody>
@@ -5936,7 +6166,7 @@
                       <a:pPr>
                         <a:defRPr sz="1100" b="1">
                           <a:solidFill>
-                            <a:srgbClr val="27AE60"/>
+                            <a:srgbClr val="2F9E41"/>
                           </a:solidFill>
                           <a:latin typeface="Segoe UI"/>
                         </a:defRPr>
@@ -6016,7 +6246,7 @@
                         </a:defRPr>
                       </a:pPr>
                       <a:r>
-                        <a:t>Dinamica de digitacao + contexto + geolocalizacao</a:t>
+                        <a:t>Dinâmica de digitação + contexto + geolocalização</a:t>
                       </a:r>
                     </a:p>
                   </a:txBody>
@@ -6034,7 +6264,7 @@
                       <a:pPr>
                         <a:defRPr sz="1100" b="1">
                           <a:solidFill>
-                            <a:srgbClr val="27AE60"/>
+                            <a:srgbClr val="2F9E41"/>
                           </a:solidFill>
                           <a:latin typeface="Segoe UI"/>
                         </a:defRPr>
@@ -6088,7 +6318,7 @@
                         </a:defRPr>
                       </a:pPr>
                       <a:r>
-                        <a:t>Multimodal (proprietario)</a:t>
+                        <a:t>Multimodal (proprietário)</a:t>
                       </a:r>
                     </a:p>
                   </a:txBody>
@@ -6114,7 +6344,7 @@
                         </a:defRPr>
                       </a:pPr>
                       <a:r>
-                        <a:t>Trilha de auditoria imutavel das decisoes de IA</a:t>
+                        <a:t>Trilha de auditoria imutável das decisões de IA</a:t>
                       </a:r>
                     </a:p>
                   </a:txBody>
@@ -6132,7 +6362,7 @@
                       <a:pPr>
                         <a:defRPr sz="1100" b="1">
                           <a:solidFill>
-                            <a:srgbClr val="27AE60"/>
+                            <a:srgbClr val="2F9E41"/>
                           </a:solidFill>
                           <a:latin typeface="Segoe UI"/>
                         </a:defRPr>
@@ -6162,7 +6392,7 @@
                         </a:defRPr>
                       </a:pPr>
                       <a:r>
-                        <a:t>Blockchain generico</a:t>
+                        <a:t>Blockchain genérico</a:t>
                       </a:r>
                     </a:p>
                   </a:txBody>
@@ -6186,7 +6416,7 @@
                         </a:defRPr>
                       </a:pPr>
                       <a:r>
-                        <a:t>Nao disponivel</a:t>
+                        <a:t>Não disponível</a:t>
                       </a:r>
                     </a:p>
                   </a:txBody>
@@ -6212,7 +6442,7 @@
                         </a:defRPr>
                       </a:pPr>
                       <a:r>
-                        <a:t>Codigo aberto e reprodutivel</a:t>
+                        <a:t>Código aberto e reprodutível</a:t>
                       </a:r>
                     </a:p>
                   </a:txBody>
@@ -6230,7 +6460,7 @@
                       <a:pPr>
                         <a:defRPr sz="1100" b="1">
                           <a:solidFill>
-                            <a:srgbClr val="27AE60"/>
+                            <a:srgbClr val="2F9E41"/>
                           </a:solidFill>
                           <a:latin typeface="Segoe UI"/>
                         </a:defRPr>
@@ -6284,7 +6514,7 @@
                         </a:defRPr>
                       </a:pPr>
                       <a:r>
-                        <a:t>Nao</a:t>
+                        <a:t>Não</a:t>
                       </a:r>
                     </a:p>
                   </a:txBody>
@@ -6328,7 +6558,7 @@
                       <a:pPr>
                         <a:defRPr sz="1100" b="1">
                           <a:solidFill>
-                            <a:srgbClr val="27AE60"/>
+                            <a:srgbClr val="2F9E41"/>
                           </a:solidFill>
                           <a:latin typeface="Segoe UI"/>
                         </a:defRPr>
@@ -6438,7 +6668,7 @@
             <a:avLst/>
           </a:prstGeom>
           <a:solidFill>
-            <a:srgbClr val="0D1B2A"/>
+            <a:srgbClr val="1A6B2A"/>
           </a:solidFill>
           <a:ln>
             <a:noFill/>
@@ -6527,13 +6757,13 @@
             <a:pPr algn="l">
               <a:defRPr sz="1400" b="0">
                 <a:solidFill>
-                  <a:srgbClr val="AACCEE"/>
+                  <a:srgbClr val="B0E0B0"/>
                 </a:solidFill>
                 <a:latin typeface="Segoe UI"/>
               </a:defRPr>
             </a:pPr>
             <a:r>
-              <a:t>Contribuicoes originais da proposta</a:t>
+              <a:t>Contribuições originais da proposta</a:t>
             </a:r>
           </a:p>
         </p:txBody>
@@ -6553,7 +6783,7 @@
             <a:avLst/>
           </a:prstGeom>
           <a:solidFill>
-            <a:srgbClr val="007ACC"/>
+            <a:srgbClr val="CD191E"/>
           </a:solidFill>
           <a:ln>
             <a:noFill/>
@@ -6598,7 +6828,7 @@
             </a:avLst>
           </a:prstGeom>
           <a:solidFill>
-            <a:srgbClr val="007ACC"/>
+            <a:srgbClr val="2F9E41"/>
           </a:solidFill>
           <a:ln>
             <a:noFill/>
@@ -6687,13 +6917,13 @@
             <a:pPr algn="l">
               <a:defRPr sz="1600" b="1">
                 <a:solidFill>
-                  <a:srgbClr val="0D1B2A"/>
+                  <a:srgbClr val="1A6B2A"/>
                 </a:solidFill>
                 <a:latin typeface="Segoe UI"/>
               </a:defRPr>
             </a:pPr>
             <a:r>
-              <a:t>Explicabilidade + Autenticacao + Blockchain</a:t>
+              <a:t>Explicabilidade + Autenticação + Blockchain</a:t>
             </a:r>
           </a:p>
         </p:txBody>
@@ -6729,7 +6959,7 @@
               </a:defRPr>
             </a:pPr>
             <a:r>
-              <a:t>Nenhum trabalho revisado implementa explicabilidade de IA especificamente para decisoes de autenticacao com registro em blockchain.</a:t>
+              <a:t>Nenhum trabalho revisado implementa explicabilidade de IA especificamente para decisões de autenticação com registro em blockchain.</a:t>
             </a:r>
           </a:p>
         </p:txBody>
@@ -6751,7 +6981,7 @@
             </a:avLst>
           </a:prstGeom>
           <a:solidFill>
-            <a:srgbClr val="27AE60"/>
+            <a:srgbClr val="2F9E41"/>
           </a:solidFill>
           <a:ln>
             <a:noFill/>
@@ -6840,7 +7070,7 @@
             <a:pPr algn="l">
               <a:defRPr sz="1600" b="1">
                 <a:solidFill>
-                  <a:srgbClr val="0D1B2A"/>
+                  <a:srgbClr val="1A6B2A"/>
                 </a:solidFill>
                 <a:latin typeface="Segoe UI"/>
               </a:defRPr>
@@ -6882,7 +7112,7 @@
               </a:defRPr>
             </a:pPr>
             <a:r>
-              <a:t>A combinacao de Hyperledger Fabric (permissionada) e Ethereum (interoperavel) para auditoria de eventos de autenticacao nao foi encontrada.</a:t>
+              <a:t>A combinação de Hyperledger Fabric (permissionada) e Ethereum (interoperável) para auditoria de eventos de autenticação não foi encontrada.</a:t>
             </a:r>
           </a:p>
         </p:txBody>
@@ -6993,7 +7223,7 @@
             <a:pPr algn="l">
               <a:defRPr sz="1600" b="1">
                 <a:solidFill>
-                  <a:srgbClr val="0D1B2A"/>
+                  <a:srgbClr val="1A6B2A"/>
                 </a:solidFill>
                 <a:latin typeface="Segoe UI"/>
               </a:defRPr>
@@ -7035,7 +7265,7 @@
               </a:defRPr>
             </a:pPr>
             <a:r>
-              <a:t>A combinacao de deteccao de anomalias (IF), classificacao (RF) e aprendizado profundo (DL) com pesos configuraveis para autenticacao e contribuicao original.</a:t>
+              <a:t>A combinação de detecção de anomalias (IF), classificação (RF) e aprendizado profundo (DL) com pesos configuráveis para autenticação é contribuição original.</a:t>
             </a:r>
           </a:p>
         </p:txBody>
@@ -7057,7 +7287,7 @@
             </a:avLst>
           </a:prstGeom>
           <a:solidFill>
-            <a:srgbClr val="C0392B"/>
+            <a:srgbClr val="CD191E"/>
           </a:solidFill>
           <a:ln>
             <a:noFill/>
@@ -7146,13 +7376,13 @@
             <a:pPr algn="l">
               <a:defRPr sz="1600" b="1">
                 <a:solidFill>
-                  <a:srgbClr val="0D1B2A"/>
+                  <a:srgbClr val="1A6B2A"/>
                 </a:solidFill>
                 <a:latin typeface="Segoe UI"/>
               </a:defRPr>
             </a:pPr>
             <a:r>
-              <a:t>Resposta Escalonada em 4 Niveis</a:t>
+              <a:t>Resposta Escalonada em 4 Níveis</a:t>
             </a:r>
           </a:p>
         </p:txBody>
@@ -7188,7 +7418,7 @@
               </a:defRPr>
             </a:pPr>
             <a:r>
-              <a:t>A granularidade de resposta (permitir, MFA, MFA+alerta, bloquear) baseada em score continuo supera as abordagens binarias predominantes.</a:t>
+              <a:t>A granularidade de resposta (permitir, MFA, MFA+alerta, bloquear) baseada em score contínuo supera as abordagens binárias predominantes.</a:t>
             </a:r>
           </a:p>
         </p:txBody>
@@ -7234,7 +7464,7 @@
             <a:avLst/>
           </a:prstGeom>
           <a:solidFill>
-            <a:srgbClr val="0D1B2A"/>
+            <a:srgbClr val="1A6B2A"/>
           </a:solidFill>
           <a:ln>
             <a:noFill/>
@@ -7293,7 +7523,7 @@
               </a:defRPr>
             </a:pPr>
             <a:r>
-              <a:t>Referencias Bibliograficas</a:t>
+              <a:t>Referências Bibliográficas</a:t>
             </a:r>
           </a:p>
         </p:txBody>
@@ -7313,7 +7543,7 @@
             <a:avLst/>
           </a:prstGeom>
           <a:solidFill>
-            <a:srgbClr val="007ACC"/>
+            <a:srgbClr val="CD191E"/>
           </a:solidFill>
           <a:ln>
             <a:noFill/>
@@ -7618,7 +7848,7 @@
     <p:bg>
       <p:bgPr>
         <a:solidFill>
-          <a:srgbClr val="0D1B2A"/>
+          <a:srgbClr val="FFFFFF"/>
         </a:solidFill>
         <a:effectLst/>
       </p:bgPr>
@@ -7639,13 +7869,13 @@
         <p:spPr>
           <a:xfrm>
             <a:off x="0" y="0"/>
-            <a:ext cx="137160" cy="6858000"/>
+            <a:ext cx="12191695" cy="1097280"/>
           </a:xfrm>
           <a:prstGeom prst="rect">
             <a:avLst/>
           </a:prstGeom>
           <a:solidFill>
-            <a:srgbClr val="007ACC"/>
+            <a:srgbClr val="2F9E41"/>
           </a:solidFill>
           <a:ln>
             <a:noFill/>
@@ -7675,56 +7905,20 @@
       </p:sp>
       <p:sp>
         <p:nvSpPr>
-          <p:cNvPr id="3" name="TextBox 2"/>
-          <p:cNvSpPr txBox="1"/>
-          <p:nvPr/>
-        </p:nvSpPr>
-        <p:spPr>
-          <a:xfrm>
-            <a:off x="1371600" y="2286000"/>
-            <a:ext cx="9144000" cy="914400"/>
-          </a:xfrm>
-          <a:prstGeom prst="rect">
-            <a:avLst/>
-          </a:prstGeom>
-          <a:noFill/>
-        </p:spPr>
-        <p:txBody>
-          <a:bodyPr wrap="square">
-            <a:spAutoFit/>
-          </a:bodyPr>
-          <a:lstStyle/>
-          <a:p>
-            <a:pPr algn="ctr">
-              <a:defRPr sz="4400" b="1">
-                <a:solidFill>
-                  <a:srgbClr val="FFFFFF"/>
-                </a:solidFill>
-                <a:latin typeface="Segoe UI"/>
-              </a:defRPr>
-            </a:pPr>
-            <a:r>
-              <a:t>Obrigado!</a:t>
-            </a:r>
-          </a:p>
-        </p:txBody>
-      </p:sp>
-      <p:sp>
-        <p:nvSpPr>
-          <p:cNvPr id="4" name="Rectangle 3"/>
+          <p:cNvPr id="3" name="Rectangle 2"/>
           <p:cNvSpPr/>
           <p:nvPr/>
         </p:nvSpPr>
         <p:spPr>
           <a:xfrm>
-            <a:off x="5029200" y="3291840"/>
-            <a:ext cx="2103120" cy="36576"/>
+            <a:off x="0" y="1097280"/>
+            <a:ext cx="12191695" cy="73152"/>
           </a:xfrm>
           <a:prstGeom prst="rect">
             <a:avLst/>
           </a:prstGeom>
           <a:solidFill>
-            <a:srgbClr val="007ACC"/>
+            <a:srgbClr val="CD191E"/>
           </a:solidFill>
           <a:ln>
             <a:noFill/>
@@ -7754,14 +7948,14 @@
       </p:sp>
       <p:sp>
         <p:nvSpPr>
-          <p:cNvPr id="5" name="TextBox 4"/>
+          <p:cNvPr id="4" name="TextBox 3"/>
           <p:cNvSpPr txBox="1"/>
           <p:nvPr/>
         </p:nvSpPr>
         <p:spPr>
           <a:xfrm>
-            <a:off x="1371600" y="3657600"/>
-            <a:ext cx="9144000" cy="548640"/>
+            <a:off x="1371600" y="320040"/>
+            <a:ext cx="9144000" cy="457200"/>
           </a:xfrm>
           <a:prstGeom prst="rect">
             <a:avLst/>
@@ -7775,29 +7969,29 @@
           <a:lstStyle/>
           <a:p>
             <a:pPr algn="ctr">
-              <a:defRPr sz="1800" b="0">
-                <a:solidFill>
-                  <a:srgbClr val="AACCEE"/>
+              <a:defRPr sz="1800" b="1">
+                <a:solidFill>
+                  <a:srgbClr val="FFFFFF"/>
                 </a:solidFill>
                 <a:latin typeface="Segoe UI"/>
               </a:defRPr>
             </a:pPr>
             <a:r>
-              <a:t>Sistema Autonomo de Autenticacao Inteligente</a:t>
-            </a:r>
-          </a:p>
-        </p:txBody>
-      </p:sp>
-      <p:sp>
-        <p:nvSpPr>
-          <p:cNvPr id="6" name="TextBox 5"/>
+              <a:t>IFBA - Instituto Federal da Bahia</a:t>
+            </a:r>
+          </a:p>
+        </p:txBody>
+      </p:sp>
+      <p:sp>
+        <p:nvSpPr>
+          <p:cNvPr id="5" name="TextBox 4"/>
           <p:cNvSpPr txBox="1"/>
           <p:nvPr/>
         </p:nvSpPr>
         <p:spPr>
           <a:xfrm>
-            <a:off x="1371600" y="4206240"/>
-            <a:ext cx="9144000" cy="457200"/>
+            <a:off x="1371600" y="2286000"/>
+            <a:ext cx="9144000" cy="914400"/>
           </a:xfrm>
           <a:prstGeom prst="rect">
             <a:avLst/>
@@ -7811,9 +8005,124 @@
           <a:lstStyle/>
           <a:p>
             <a:pPr algn="ctr">
+              <a:defRPr sz="4800" b="1">
+                <a:solidFill>
+                  <a:srgbClr val="1A6B2A"/>
+                </a:solidFill>
+                <a:latin typeface="Segoe UI"/>
+              </a:defRPr>
+            </a:pPr>
+            <a:r>
+              <a:t>Obrigado!</a:t>
+            </a:r>
+          </a:p>
+        </p:txBody>
+      </p:sp>
+      <p:sp>
+        <p:nvSpPr>
+          <p:cNvPr id="6" name="Rectangle 5"/>
+          <p:cNvSpPr/>
+          <p:nvPr/>
+        </p:nvSpPr>
+        <p:spPr>
+          <a:xfrm>
+            <a:off x="4572000" y="3291840"/>
+            <a:ext cx="3017520" cy="36576"/>
+          </a:xfrm>
+          <a:prstGeom prst="rect">
+            <a:avLst/>
+          </a:prstGeom>
+          <a:solidFill>
+            <a:srgbClr val="2F9E41"/>
+          </a:solidFill>
+          <a:ln>
+            <a:noFill/>
+          </a:ln>
+        </p:spPr>
+        <p:style>
+          <a:lnRef idx="1">
+            <a:schemeClr val="accent1"/>
+          </a:lnRef>
+          <a:fillRef idx="3">
+            <a:schemeClr val="accent1"/>
+          </a:fillRef>
+          <a:effectRef idx="2">
+            <a:schemeClr val="accent1"/>
+          </a:effectRef>
+          <a:fontRef idx="minor">
+            <a:schemeClr val="lt1"/>
+          </a:fontRef>
+        </p:style>
+        <p:txBody>
+          <a:bodyPr rtlCol="0" anchor="ctr"/>
+          <a:lstStyle/>
+          <a:p>
+            <a:pPr algn="ctr"/>
+          </a:p>
+        </p:txBody>
+      </p:sp>
+      <p:sp>
+        <p:nvSpPr>
+          <p:cNvPr id="7" name="TextBox 6"/>
+          <p:cNvSpPr txBox="1"/>
+          <p:nvPr/>
+        </p:nvSpPr>
+        <p:spPr>
+          <a:xfrm>
+            <a:off x="1371600" y="3657600"/>
+            <a:ext cx="9144000" cy="548640"/>
+          </a:xfrm>
+          <a:prstGeom prst="rect">
+            <a:avLst/>
+          </a:prstGeom>
+          <a:noFill/>
+        </p:spPr>
+        <p:txBody>
+          <a:bodyPr wrap="square">
+            <a:spAutoFit/>
+          </a:bodyPr>
+          <a:lstStyle/>
+          <a:p>
+            <a:pPr algn="ctr">
+              <a:defRPr sz="1800" b="1">
+                <a:solidFill>
+                  <a:srgbClr val="1A6B2A"/>
+                </a:solidFill>
+                <a:latin typeface="Segoe UI"/>
+              </a:defRPr>
+            </a:pPr>
+            <a:r>
+              <a:t>Sistema Autônomo de Autenticação Inteligente</a:t>
+            </a:r>
+          </a:p>
+        </p:txBody>
+      </p:sp>
+      <p:sp>
+        <p:nvSpPr>
+          <p:cNvPr id="8" name="TextBox 7"/>
+          <p:cNvSpPr txBox="1"/>
+          <p:nvPr/>
+        </p:nvSpPr>
+        <p:spPr>
+          <a:xfrm>
+            <a:off x="1371600" y="4206240"/>
+            <a:ext cx="9144000" cy="457200"/>
+          </a:xfrm>
+          <a:prstGeom prst="rect">
+            <a:avLst/>
+          </a:prstGeom>
+          <a:noFill/>
+        </p:spPr>
+        <p:txBody>
+          <a:bodyPr wrap="square">
+            <a:spAutoFit/>
+          </a:bodyPr>
+          <a:lstStyle/>
+          <a:p>
+            <a:pPr algn="ctr">
               <a:defRPr sz="1400" b="0">
                 <a:solidFill>
-                  <a:srgbClr val="88AACC"/>
+                  <a:srgbClr val="4A4A4A"/>
                 </a:solidFill>
                 <a:latin typeface="Segoe UI"/>
               </a:defRPr>
@@ -7821,6 +8130,92 @@
             <a:r>
               <a:t>Trabalhos Relacionados e Estado da Arte</a:t>
             </a:r>
+          </a:p>
+        </p:txBody>
+      </p:sp>
+      <p:sp>
+        <p:nvSpPr>
+          <p:cNvPr id="9" name="Rectangle 8"/>
+          <p:cNvSpPr/>
+          <p:nvPr/>
+        </p:nvSpPr>
+        <p:spPr>
+          <a:xfrm>
+            <a:off x="0" y="6217920"/>
+            <a:ext cx="12191695" cy="73152"/>
+          </a:xfrm>
+          <a:prstGeom prst="rect">
+            <a:avLst/>
+          </a:prstGeom>
+          <a:solidFill>
+            <a:srgbClr val="CD191E"/>
+          </a:solidFill>
+          <a:ln>
+            <a:noFill/>
+          </a:ln>
+        </p:spPr>
+        <p:style>
+          <a:lnRef idx="1">
+            <a:schemeClr val="accent1"/>
+          </a:lnRef>
+          <a:fillRef idx="3">
+            <a:schemeClr val="accent1"/>
+          </a:fillRef>
+          <a:effectRef idx="2">
+            <a:schemeClr val="accent1"/>
+          </a:effectRef>
+          <a:fontRef idx="minor">
+            <a:schemeClr val="lt1"/>
+          </a:fontRef>
+        </p:style>
+        <p:txBody>
+          <a:bodyPr rtlCol="0" anchor="ctr"/>
+          <a:lstStyle/>
+          <a:p>
+            <a:pPr algn="ctr"/>
+          </a:p>
+        </p:txBody>
+      </p:sp>
+      <p:sp>
+        <p:nvSpPr>
+          <p:cNvPr id="10" name="Rectangle 9"/>
+          <p:cNvSpPr/>
+          <p:nvPr/>
+        </p:nvSpPr>
+        <p:spPr>
+          <a:xfrm>
+            <a:off x="0" y="6291072"/>
+            <a:ext cx="12191695" cy="566928"/>
+          </a:xfrm>
+          <a:prstGeom prst="rect">
+            <a:avLst/>
+          </a:prstGeom>
+          <a:solidFill>
+            <a:srgbClr val="2F9E41"/>
+          </a:solidFill>
+          <a:ln>
+            <a:noFill/>
+          </a:ln>
+        </p:spPr>
+        <p:style>
+          <a:lnRef idx="1">
+            <a:schemeClr val="accent1"/>
+          </a:lnRef>
+          <a:fillRef idx="3">
+            <a:schemeClr val="accent1"/>
+          </a:fillRef>
+          <a:effectRef idx="2">
+            <a:schemeClr val="accent1"/>
+          </a:effectRef>
+          <a:fontRef idx="minor">
+            <a:schemeClr val="lt1"/>
+          </a:fontRef>
+        </p:style>
+        <p:txBody>
+          <a:bodyPr rtlCol="0" anchor="ctr"/>
+          <a:lstStyle/>
+          <a:p>
+            <a:pPr algn="ctr"/>
           </a:p>
         </p:txBody>
       </p:sp>
@@ -7865,7 +8260,7 @@
             <a:avLst/>
           </a:prstGeom>
           <a:solidFill>
-            <a:srgbClr val="0D1B2A"/>
+            <a:srgbClr val="1A6B2A"/>
           </a:solidFill>
           <a:ln>
             <a:noFill/>
@@ -7944,7 +8339,7 @@
             <a:avLst/>
           </a:prstGeom>
           <a:solidFill>
-            <a:srgbClr val="007ACC"/>
+            <a:srgbClr val="CD191E"/>
           </a:solidFill>
           <a:ln>
             <a:noFill/>
@@ -7989,7 +8384,7 @@
             </a:avLst>
           </a:prstGeom>
           <a:solidFill>
-            <a:srgbClr val="007ACC"/>
+            <a:srgbClr val="2F9E41"/>
           </a:solidFill>
           <a:ln>
             <a:noFill/>
@@ -8084,7 +8479,7 @@
               </a:defRPr>
             </a:pPr>
             <a:r>
-              <a:t>Contexto e Objetivo da Revisao</a:t>
+              <a:t>Contexto e Objetivo da Revisão</a:t>
             </a:r>
           </a:p>
         </p:txBody>
@@ -8106,7 +8501,7 @@
             </a:avLst>
           </a:prstGeom>
           <a:solidFill>
-            <a:srgbClr val="007ACC"/>
+            <a:srgbClr val="2F9E41"/>
           </a:solidFill>
           <a:ln>
             <a:noFill/>
@@ -8223,7 +8618,7 @@
             </a:avLst>
           </a:prstGeom>
           <a:solidFill>
-            <a:srgbClr val="007ACC"/>
+            <a:srgbClr val="2F9E41"/>
           </a:solidFill>
           <a:ln>
             <a:noFill/>
@@ -8340,7 +8735,7 @@
             </a:avLst>
           </a:prstGeom>
           <a:solidFill>
-            <a:srgbClr val="007ACC"/>
+            <a:srgbClr val="2F9E41"/>
           </a:solidFill>
           <a:ln>
             <a:noFill/>
@@ -8435,7 +8830,7 @@
               </a:defRPr>
             </a:pPr>
             <a:r>
-              <a:t>Trabalhos Academicos (12 estudos)</a:t>
+              <a:t>Trabalhos Acadêmicos (12 estudos)</a:t>
             </a:r>
           </a:p>
         </p:txBody>
@@ -8457,7 +8852,7 @@
             </a:avLst>
           </a:prstGeom>
           <a:solidFill>
-            <a:srgbClr val="007ACC"/>
+            <a:srgbClr val="2F9E41"/>
           </a:solidFill>
           <a:ln>
             <a:noFill/>
@@ -8552,7 +8947,7 @@
               </a:defRPr>
             </a:pPr>
             <a:r>
-              <a:t>Solucoes da Industria</a:t>
+              <a:t>Soluções da Indústria</a:t>
             </a:r>
           </a:p>
         </p:txBody>
@@ -8574,7 +8969,7 @@
             </a:avLst>
           </a:prstGeom>
           <a:solidFill>
-            <a:srgbClr val="007ACC"/>
+            <a:srgbClr val="2F9E41"/>
           </a:solidFill>
           <a:ln>
             <a:noFill/>
@@ -8669,7 +9064,7 @@
               </a:defRPr>
             </a:pPr>
             <a:r>
-              <a:t>Sintese Comparativa e Diferenciais</a:t>
+              <a:t>Síntese Comparativa e Diferenciais</a:t>
             </a:r>
           </a:p>
         </p:txBody>
@@ -8691,7 +9086,7 @@
             </a:avLst>
           </a:prstGeom>
           <a:solidFill>
-            <a:srgbClr val="007ACC"/>
+            <a:srgbClr val="2F9E41"/>
           </a:solidFill>
           <a:ln>
             <a:noFill/>
@@ -8832,7 +9227,7 @@
             <a:avLst/>
           </a:prstGeom>
           <a:solidFill>
-            <a:srgbClr val="0D1B2A"/>
+            <a:srgbClr val="1A6B2A"/>
           </a:solidFill>
           <a:ln>
             <a:noFill/>
@@ -8891,7 +9286,7 @@
               </a:defRPr>
             </a:pPr>
             <a:r>
-              <a:t>Contexto e Objetivo da Revisao</a:t>
+              <a:t>Contexto e Objetivo da Revisão</a:t>
             </a:r>
           </a:p>
         </p:txBody>
@@ -8911,7 +9306,7 @@
             <a:avLst/>
           </a:prstGeom>
           <a:solidFill>
-            <a:srgbClr val="007ACC"/>
+            <a:srgbClr val="CD191E"/>
           </a:solidFill>
           <a:ln>
             <a:noFill/>
@@ -8970,7 +9365,7 @@
               </a:defRPr>
             </a:pPr>
             <a:r>
-              <a:t>O sistema proposto integra multiplas tecnologias em uma plataforma unica de autenticacao inteligente. Esta revisao identifica e compara trabalhos da literatura academica e da industria que abordam, de forma isolada ou parcial, os mesmos eixos tematicos.</a:t>
+              <a:t>O sistema proposto integra múltiplas tecnologias em uma plataforma única de autenticação inteligente. Esta revisão identifica e compara trabalhos da literatura acadêmica e da indústria que abordam, de forma isolada ou parcial, os mesmos eixos temáticos.</a:t>
             </a:r>
           </a:p>
         </p:txBody>
@@ -9045,7 +9440,7 @@
             <a:pPr algn="l">
               <a:defRPr sz="1400" b="1">
                 <a:solidFill>
-                  <a:srgbClr val="007ACC"/>
+                  <a:srgbClr val="2F9E41"/>
                 </a:solidFill>
                 <a:latin typeface="Segoe UI"/>
               </a:defRPr>
@@ -9213,7 +9608,7 @@
             <a:pPr algn="l">
               <a:defRPr sz="1400" b="1">
                 <a:solidFill>
-                  <a:srgbClr val="27AE60"/>
+                  <a:srgbClr val="2F9E41"/>
                 </a:solidFill>
                 <a:latin typeface="Segoe UI"/>
               </a:defRPr>
@@ -9258,7 +9653,7 @@
               </a:defRPr>
             </a:pPr>
             <a:r>
-              <a:t>• Dinamica de digitacao</a:t>
+              <a:t>• Dinâmica de digitação</a:t>
             </a:r>
           </a:p>
           <a:p>
@@ -9274,7 +9669,7 @@
               </a:defRPr>
             </a:pPr>
             <a:r>
-              <a:t>• Geolocalizacao por IP</a:t>
+              <a:t>• Geolocalização por IP</a:t>
             </a:r>
           </a:p>
           <a:p>
@@ -9290,7 +9685,7 @@
               </a:defRPr>
             </a:pPr>
             <a:r>
-              <a:t>• Analise de sessao</a:t>
+              <a:t>• Análise de sessão</a:t>
             </a:r>
           </a:p>
           <a:p>
@@ -9458,7 +9853,7 @@
               </a:defRPr>
             </a:pPr>
             <a:r>
-              <a:t>• Auditoria imutavel</a:t>
+              <a:t>• Auditoria imutável</a:t>
             </a:r>
           </a:p>
           <a:p>
@@ -9520,7 +9915,7 @@
             <a:avLst/>
           </a:prstGeom>
           <a:solidFill>
-            <a:srgbClr val="0D1B2A"/>
+            <a:srgbClr val="1A6B2A"/>
           </a:solidFill>
           <a:ln>
             <a:noFill/>
@@ -9609,13 +10004,13 @@
             <a:pPr algn="l">
               <a:defRPr sz="1400" b="0">
                 <a:solidFill>
-                  <a:srgbClr val="AACCEE"/>
+                  <a:srgbClr val="B0E0B0"/>
                 </a:solidFill>
                 <a:latin typeface="Segoe UI"/>
               </a:defRPr>
             </a:pPr>
             <a:r>
-              <a:t>Trabalhos Academicos (1/2)</a:t>
+              <a:t>Trabalhos Acadêmicos (1/2)</a:t>
             </a:r>
           </a:p>
         </p:txBody>
@@ -9635,7 +10030,7 @@
             <a:avLst/>
           </a:prstGeom>
           <a:solidFill>
-            <a:srgbClr val="007ACC"/>
+            <a:srgbClr val="CD191E"/>
           </a:solidFill>
           <a:ln>
             <a:noFill/>
@@ -9709,7 +10104,7 @@
                   </a:txBody>
                   <a:tcPr>
                     <a:solidFill>
-                      <a:srgbClr val="0D1B2A"/>
+                      <a:srgbClr val="1A6B2A"/>
                     </a:solidFill>
                   </a:tcPr>
                 </a:tc>
@@ -9733,7 +10128,7 @@
                   </a:txBody>
                   <a:tcPr>
                     <a:solidFill>
-                      <a:srgbClr val="0D1B2A"/>
+                      <a:srgbClr val="1A6B2A"/>
                     </a:solidFill>
                   </a:tcPr>
                 </a:tc>
@@ -9757,7 +10152,7 @@
                   </a:txBody>
                   <a:tcPr>
                     <a:solidFill>
-                      <a:srgbClr val="0D1B2A"/>
+                      <a:srgbClr val="1A6B2A"/>
                     </a:solidFill>
                   </a:tcPr>
                 </a:tc>
@@ -9781,7 +10176,7 @@
                   </a:txBody>
                   <a:tcPr>
                     <a:solidFill>
-                      <a:srgbClr val="0D1B2A"/>
+                      <a:srgbClr val="1A6B2A"/>
                     </a:solidFill>
                   </a:tcPr>
                 </a:tc>
@@ -9799,13 +10194,13 @@
                         </a:defRPr>
                       </a:pPr>
                       <a:r>
-                        <a:t>Metricas</a:t>
+                        <a:t>Métricas</a:t>
                       </a:r>
                     </a:p>
                   </a:txBody>
                   <a:tcPr>
                     <a:solidFill>
-                      <a:srgbClr val="0D1B2A"/>
+                      <a:srgbClr val="1A6B2A"/>
                     </a:solidFill>
                   </a:tcPr>
                 </a:tc>
@@ -9873,7 +10268,7 @@
                         </a:defRPr>
                       </a:pPr>
                       <a:r>
-                        <a:t>Mapear estado da arte em autenticacao biometrica adaptativa</a:t>
+                        <a:t>Mapear estado da arte em autenticação biométrica adaptativa</a:t>
                       </a:r>
                     </a:p>
                   </a:txBody>
@@ -9897,7 +10292,7 @@
                         </a:defRPr>
                       </a:pPr>
                       <a:r>
-                        <a:t>Revisao de 80+ trabalhos</a:t>
+                        <a:t>Revisão de 80+ trabalhos</a:t>
                       </a:r>
                     </a:p>
                   </a:txBody>
@@ -10117,7 +10512,7 @@
                         </a:defRPr>
                       </a:pPr>
                       <a:r>
-                        <a:t>Autenticacao continua em dispositivos moveis</a:t>
+                        <a:t>Autenticação contínua em dispositivos móveis</a:t>
                       </a:r>
                     </a:p>
                   </a:txBody>
@@ -10165,7 +10560,7 @@
                         </a:defRPr>
                       </a:pPr>
                       <a:r>
-                        <a:t>Acuracia, EER, F1</a:t>
+                        <a:t>Acurácia, EER, F1</a:t>
                       </a:r>
                     </a:p>
                   </a:txBody>
@@ -10239,7 +10634,7 @@
                         </a:defRPr>
                       </a:pPr>
                       <a:r>
-                        <a:t>Autenticacao por padroes de digitacao</a:t>
+                        <a:t>Autenticação por padrões de digitação</a:t>
                       </a:r>
                     </a:p>
                   </a:txBody>
@@ -10361,7 +10756,7 @@
                         </a:defRPr>
                       </a:pPr>
                       <a:r>
-                        <a:t>Auditoria imutavel com blockchain</a:t>
+                        <a:t>Auditoria imutável com blockchain</a:t>
                       </a:r>
                     </a:p>
                   </a:txBody>
@@ -10409,7 +10804,7 @@
                         </a:defRPr>
                       </a:pPr>
                       <a:r>
-                        <a:t>Throughput, latencia</a:t>
+                        <a:t>Throughput, latência</a:t>
                       </a:r>
                     </a:p>
                   </a:txBody>
@@ -10483,7 +10878,7 @@
                         </a:defRPr>
                       </a:pPr>
                       <a:r>
-                        <a:t>Logs imutaveis com privacidade</a:t>
+                        <a:t>Logs imutáveis com privacidade</a:t>
                       </a:r>
                     </a:p>
                   </a:txBody>
@@ -10531,7 +10926,7 @@
                         </a:defRPr>
                       </a:pPr>
                       <a:r>
-                        <a:t>Latencia, overhead</a:t>
+                        <a:t>Latência, overhead</a:t>
                       </a:r>
                     </a:p>
                   </a:txBody>
@@ -10605,7 +11000,7 @@
                         </a:defRPr>
                       </a:pPr>
                       <a:r>
-                        <a:t>IAM com blockchain para saude</a:t>
+                        <a:t>IAM com blockchain para saúde</a:t>
                       </a:r>
                     </a:p>
                   </a:txBody>
@@ -10629,7 +11024,7 @@
                         </a:defRPr>
                       </a:pPr>
                       <a:r>
-                        <a:t>Prototipo Hyperledger</a:t>
+                        <a:t>Protótipo Hyperledger</a:t>
                       </a:r>
                     </a:p>
                   </a:txBody>
@@ -10653,7 +11048,7 @@
                         </a:defRPr>
                       </a:pPr>
                       <a:r>
-                        <a:t>Escalabilidade, seguranca</a:t>
+                        <a:t>Escalabilidade, segurança</a:t>
                       </a:r>
                     </a:p>
                   </a:txBody>
@@ -10709,7 +11104,7 @@
             <a:avLst/>
           </a:prstGeom>
           <a:solidFill>
-            <a:srgbClr val="0D1B2A"/>
+            <a:srgbClr val="1A6B2A"/>
           </a:solidFill>
           <a:ln>
             <a:noFill/>
@@ -10798,13 +11193,13 @@
             <a:pPr algn="l">
               <a:defRPr sz="1400" b="0">
                 <a:solidFill>
-                  <a:srgbClr val="AACCEE"/>
+                  <a:srgbClr val="B0E0B0"/>
                 </a:solidFill>
                 <a:latin typeface="Segoe UI"/>
               </a:defRPr>
             </a:pPr>
             <a:r>
-              <a:t>Trabalhos Academicos (2/2) + Industria</a:t>
+              <a:t>Trabalhos Acadêmicos (2/2) + Indústria</a:t>
             </a:r>
           </a:p>
         </p:txBody>
@@ -10824,7 +11219,7 @@
             <a:avLst/>
           </a:prstGeom>
           <a:solidFill>
-            <a:srgbClr val="007ACC"/>
+            <a:srgbClr val="CD191E"/>
           </a:solidFill>
           <a:ln>
             <a:noFill/>
@@ -10898,7 +11293,7 @@
                   </a:txBody>
                   <a:tcPr>
                     <a:solidFill>
-                      <a:srgbClr val="0D1B2A"/>
+                      <a:srgbClr val="1A6B2A"/>
                     </a:solidFill>
                   </a:tcPr>
                 </a:tc>
@@ -10922,7 +11317,7 @@
                   </a:txBody>
                   <a:tcPr>
                     <a:solidFill>
-                      <a:srgbClr val="0D1B2A"/>
+                      <a:srgbClr val="1A6B2A"/>
                     </a:solidFill>
                   </a:tcPr>
                 </a:tc>
@@ -10946,7 +11341,7 @@
                   </a:txBody>
                   <a:tcPr>
                     <a:solidFill>
-                      <a:srgbClr val="0D1B2A"/>
+                      <a:srgbClr val="1A6B2A"/>
                     </a:solidFill>
                   </a:tcPr>
                 </a:tc>
@@ -10970,7 +11365,7 @@
                   </a:txBody>
                   <a:tcPr>
                     <a:solidFill>
-                      <a:srgbClr val="0D1B2A"/>
+                      <a:srgbClr val="1A6B2A"/>
                     </a:solidFill>
                   </a:tcPr>
                 </a:tc>
@@ -10988,13 +11383,13 @@
                         </a:defRPr>
                       </a:pPr>
                       <a:r>
-                        <a:t>Metricas</a:t>
+                        <a:t>Métricas</a:t>
                       </a:r>
                     </a:p>
                   </a:txBody>
                   <a:tcPr>
                     <a:solidFill>
-                      <a:srgbClr val="0D1B2A"/>
+                      <a:srgbClr val="1A6B2A"/>
                     </a:solidFill>
                   </a:tcPr>
                 </a:tc>
@@ -11062,7 +11457,7 @@
                         </a:defRPr>
                       </a:pPr>
                       <a:r>
-                        <a:t>Classificar logins por nivel de risco</a:t>
+                        <a:t>Classificar logins por nível de risco</a:t>
                       </a:r>
                     </a:p>
                   </a:txBody>
@@ -11110,7 +11505,7 @@
                         </a:defRPr>
                       </a:pPr>
                       <a:r>
-                        <a:t>Acuracia, precisao, recall</a:t>
+                        <a:t>Acurácia, precisão, recall</a:t>
                       </a:r>
                     </a:p>
                   </a:txBody>
@@ -11184,7 +11579,7 @@
                         </a:defRPr>
                       </a:pPr>
                       <a:r>
-                        <a:t>Score de confianca dinamico passwordless</a:t>
+                        <a:t>Score de confiança dinâmico passwordless</a:t>
                       </a:r>
                     </a:p>
                   </a:txBody>
@@ -11208,7 +11603,7 @@
                         </a:defRPr>
                       </a:pPr>
                       <a:r>
-                        <a:t>Avaliacao em moveis/wearables</a:t>
+                        <a:t>Avaliação em móveis/wearables</a:t>
                       </a:r>
                     </a:p>
                   </a:txBody>
@@ -11306,7 +11701,7 @@
                         </a:defRPr>
                       </a:pPr>
                       <a:r>
-                        <a:t>Decisoes adaptativas com RL</a:t>
+                        <a:t>Decisões adaptativas com RL</a:t>
                       </a:r>
                     </a:p>
                   </a:txBody>
@@ -11354,7 +11749,7 @@
                         </a:defRPr>
                       </a:pPr>
                       <a:r>
-                        <a:t>Reducao falsos positivos</a:t>
+                        <a:t>Redução falsos positivos</a:t>
                       </a:r>
                     </a:p>
                   </a:txBody>
@@ -11428,7 +11823,7 @@
                         </a:defRPr>
                       </a:pPr>
                       <a:r>
-                        <a:t>Explicabilidade em sistemas de seguranca</a:t>
+                        <a:t>Explicabilidade em sistemas de segurança</a:t>
                       </a:r>
                     </a:p>
                   </a:txBody>
@@ -11452,7 +11847,7 @@
                         </a:defRPr>
                       </a:pPr>
                       <a:r>
-                        <a:t>Analise SHAP/LIME em IDS</a:t>
+                        <a:t>Análise SHAP/LIME em IDS</a:t>
                       </a:r>
                     </a:p>
                   </a:txBody>
@@ -11550,7 +11945,7 @@
                         </a:defRPr>
                       </a:pPr>
                       <a:r>
-                        <a:t>Deteccao de deriva comportamental</a:t>
+                        <a:t>Detecção de deriva comportamental</a:t>
                       </a:r>
                     </a:p>
                   </a:txBody>
@@ -11598,7 +11993,7 @@
                         </a:defRPr>
                       </a:pPr>
                       <a:r>
-                        <a:t>Acuracia de deteccao</a:t>
+                        <a:t>Acurácia de detecção</a:t>
                       </a:r>
                     </a:p>
                   </a:txBody>
@@ -11624,7 +12019,7 @@
                         </a:defRPr>
                       </a:pPr>
                       <a:r>
-                        <a:t>IBM Trusteer (Industria)</a:t>
+                        <a:t>IBM Trusteer (Indústria)</a:t>
                       </a:r>
                     </a:p>
                   </a:txBody>
@@ -11672,7 +12067,7 @@
                         </a:defRPr>
                       </a:pPr>
                       <a:r>
-                        <a:t>Prevencao de fraude com biometria IA</a:t>
+                        <a:t>Prevenção de fraude com biometria IA</a:t>
                       </a:r>
                     </a:p>
                   </a:txBody>
@@ -11696,7 +12091,7 @@
                         </a:defRPr>
                       </a:pPr>
                       <a:r>
-                        <a:t>Producao em inst. financeiras</a:t>
+                        <a:t>Produção em inst. financeiras</a:t>
                       </a:r>
                     </a:p>
                   </a:txBody>
@@ -11720,7 +12115,7 @@
                         </a:defRPr>
                       </a:pPr>
                       <a:r>
-                        <a:t>Proprietario (nao publicado)</a:t>
+                        <a:t>Proprietário (não publicado)</a:t>
                       </a:r>
                     </a:p>
                   </a:txBody>
@@ -11746,7 +12141,7 @@
                         </a:defRPr>
                       </a:pPr>
                       <a:r>
-                        <a:t>BioCatch (Industria)</a:t>
+                        <a:t>BioCatch (Indústria)</a:t>
                       </a:r>
                     </a:p>
                   </a:txBody>
@@ -11818,7 +12213,7 @@
                         </a:defRPr>
                       </a:pPr>
                       <a:r>
-                        <a:t>Producao em bancos/fintechs</a:t>
+                        <a:t>Produção em bancos/fintechs</a:t>
                       </a:r>
                     </a:p>
                   </a:txBody>
@@ -11842,7 +12237,7 @@
                         </a:defRPr>
                       </a:pPr>
                       <a:r>
-                        <a:t>Proprietario (nao publicado)</a:t>
+                        <a:t>Proprietário (não publicado)</a:t>
                       </a:r>
                     </a:p>
                   </a:txBody>
@@ -11898,7 +12293,7 @@
             <a:avLst/>
           </a:prstGeom>
           <a:solidFill>
-            <a:srgbClr val="0D1B2A"/>
+            <a:srgbClr val="1A6B2A"/>
           </a:solidFill>
           <a:ln>
             <a:noFill/>
@@ -11987,7 +12382,7 @@
             <a:pPr algn="l">
               <a:defRPr sz="1400" b="0">
                 <a:solidFill>
-                  <a:srgbClr val="AACCEE"/>
+                  <a:srgbClr val="B0E0B0"/>
                 </a:solidFill>
                 <a:latin typeface="Segoe UI"/>
               </a:defRPr>
@@ -12013,7 +12408,7 @@
             <a:avLst/>
           </a:prstGeom>
           <a:solidFill>
-            <a:srgbClr val="007ACC"/>
+            <a:srgbClr val="CD191E"/>
           </a:solidFill>
           <a:ln>
             <a:noFill/>
@@ -12111,7 +12506,7 @@
             <a:pPr algn="l">
               <a:defRPr sz="1600" b="1">
                 <a:solidFill>
-                  <a:srgbClr val="007ACC"/>
+                  <a:srgbClr val="2F9E41"/>
                 </a:solidFill>
                 <a:latin typeface="Segoe UI"/>
               </a:defRPr>
@@ -12204,7 +12599,7 @@
               </a:defRPr>
             </a:pPr>
             <a:r>
-              <a:t>• Termos: autenticacao adaptativa, login inteligente, biometria comportamental</a:t>
+              <a:t>• Termos: autenticação adaptativa, login inteligente, biometria comportamental</a:t>
             </a:r>
           </a:p>
         </p:txBody>
@@ -12279,7 +12674,7 @@
             <a:pPr algn="l">
               <a:defRPr sz="1600" b="1">
                 <a:solidFill>
-                  <a:srgbClr val="007ACC"/>
+                  <a:srgbClr val="2F9E41"/>
                 </a:solidFill>
                 <a:latin typeface="Segoe UI"/>
               </a:defRPr>
@@ -12324,7 +12719,7 @@
               </a:defRPr>
             </a:pPr>
             <a:r>
-              <a:t>• Consulta publica sobre patentes de IA</a:t>
+              <a:t>• Consulta pública sobre patentes de IA</a:t>
             </a:r>
           </a:p>
           <a:p>
@@ -12340,7 +12735,7 @@
               </a:defRPr>
             </a:pPr>
             <a:r>
-              <a:t>• Categorias: modelos de IA, invencoes baseadas em IA, invencoes assistidas por IA</a:t>
+              <a:t>• Categorias: modelos de IA, invenções baseadas em IA, invenções assistidas por IA</a:t>
             </a:r>
           </a:p>
           <a:p>
@@ -12356,7 +12751,7 @@
               </a:defRPr>
             </a:pPr>
             <a:r>
-              <a:t>• Amadurecimento regulatorio para protecao futura</a:t>
+              <a:t>• Amadurecimento regulatório para proteção futura</a:t>
             </a:r>
           </a:p>
         </p:txBody>
@@ -12431,13 +12826,13 @@
             <a:pPr algn="l">
               <a:defRPr sz="1600" b="1">
                 <a:solidFill>
-                  <a:srgbClr val="27AE60"/>
+                  <a:srgbClr val="2F9E41"/>
                 </a:solidFill>
                 <a:latin typeface="Segoe UI"/>
               </a:defRPr>
             </a:pPr>
             <a:r>
-              <a:t>Relacao com a Proposta</a:t>
+              <a:t>Relação com a Proposta</a:t>
             </a:r>
           </a:p>
         </p:txBody>
@@ -12473,7 +12868,7 @@
               </a:defRPr>
             </a:pPr>
             <a:r>
-              <a:t>A ausencia de patentes no INPI que integrem autenticacao adaptativa com ML, biometria comportamental, blockchain e explicabilidade de IA evidencia o carater inovador da proposta. O sistema se posiciona em uma lacuna de propriedade intelectual no cenario brasileiro, combinando elementos que, individualmente, ja possuem registro, mas que em conjunto representam uma contribuicao original.</a:t>
+              <a:t>A ausência de patentes no INPI que integrem autenticação adaptativa com ML, biometria comportamental, blockchain e explicabilidade de IA evidencia o caráter inovador da proposta. O sistema se posiciona em uma lacuna de propriedade intelectual no cenário brasileiro, combinando elementos que, individualmente, já possuem registro, mas que em conjunto representam uma contribuição original.</a:t>
             </a:r>
           </a:p>
         </p:txBody>
@@ -12519,7 +12914,7 @@
             <a:avLst/>
           </a:prstGeom>
           <a:solidFill>
-            <a:srgbClr val="0D1B2A"/>
+            <a:srgbClr val="1A6B2A"/>
           </a:solidFill>
           <a:ln>
             <a:noFill/>
@@ -12608,13 +13003,13 @@
             <a:pPr algn="l">
               <a:defRPr sz="1400" b="0">
                 <a:solidFill>
-                  <a:srgbClr val="AACCEE"/>
+                  <a:srgbClr val="B0E0B0"/>
                 </a:solidFill>
                 <a:latin typeface="Segoe UI"/>
               </a:defRPr>
             </a:pPr>
             <a:r>
-              <a:t>ScienceDirect, 2023 - Revisao Sistematica</a:t>
+              <a:t>ScienceDirect, 2023 - Revisão Sistemática</a:t>
             </a:r>
           </a:p>
         </p:txBody>
@@ -12634,7 +13029,7 @@
             <a:avLst/>
           </a:prstGeom>
           <a:solidFill>
-            <a:srgbClr val="007ACC"/>
+            <a:srgbClr val="CD191E"/>
           </a:solidFill>
           <a:ln>
             <a:noFill/>
@@ -12732,13 +13127,13 @@
             <a:pPr algn="l">
               <a:defRPr sz="1400" b="1">
                 <a:solidFill>
-                  <a:srgbClr val="007ACC"/>
+                  <a:srgbClr val="2F9E41"/>
                 </a:solidFill>
                 <a:latin typeface="Segoe UI"/>
               </a:defRPr>
             </a:pPr>
             <a:r>
-              <a:t>Descricao do Trabalho</a:t>
+              <a:t>Descrição do Trabalho</a:t>
             </a:r>
           </a:p>
         </p:txBody>
@@ -12774,7 +13169,7 @@
               </a:defRPr>
             </a:pPr>
             <a:r>
-              <a:t>Revisao sistematica que analisa mais de 80 trabalhos sobre sistemas de autenticacao biometrica adaptativos. Mapeia como esses sistemas ajustam dinamicamente seus processos de amostragem e reconhecimento em resposta a mudancas no ambiente operacional. Identifica desafios criticos como ameacas a privacidade, spoofing e acessibilidade.</a:t>
+              <a:t>Revisão sistemática que analisa mais de 80 trabalhos sobre sistemas de autenticação biométrica adaptativos. Mapeia como esses sistemas ajustam dinamicamente seus processos de amostragem e reconhecimento em resposta a mudanças no ambiente operacional. Identifica desafios críticos como ameaças à privacidade, spoofing e acessibilidade.</a:t>
             </a:r>
           </a:p>
         </p:txBody>
@@ -12849,13 +13244,13 @@
             <a:pPr algn="l">
               <a:defRPr sz="1400" b="1">
                 <a:solidFill>
-                  <a:srgbClr val="27AE60"/>
+                  <a:srgbClr val="2F9E41"/>
                 </a:solidFill>
                 <a:latin typeface="Segoe UI"/>
               </a:defRPr>
             </a:pPr>
             <a:r>
-              <a:t>Comparacao com a Proposta</a:t>
+              <a:t>Comparação com a Proposta</a:t>
             </a:r>
           </a:p>
         </p:txBody>
@@ -12891,7 +13286,7 @@
               </a:defRPr>
             </a:pPr>
             <a:r>
-              <a:t>O sistema proposto implementa concretamente uma solucao adaptativa com ensemble de ML (Isolation Forest + Random Forest + Deep Learning), MFA condicional baseado em risco, e deteccao de deriva comportamental. Adiciona blockchain e explicabilidade de IA — elementos nao cobertos na revisao.</a:t>
+              <a:t>O sistema proposto implementa concretamente uma solução adaptativa com ensemble de ML (Isolation Forest + Random Forest + Deep Learning), MFA condicional baseado em risco, e detecção de deriva comportamental. Adiciona blockchain e explicabilidade de IA — elementos não cobertos na revisão.</a:t>
             </a:r>
           </a:p>
         </p:txBody>
@@ -12937,7 +13332,7 @@
             <a:avLst/>
           </a:prstGeom>
           <a:solidFill>
-            <a:srgbClr val="0D1B2A"/>
+            <a:srgbClr val="1A6B2A"/>
           </a:solidFill>
           <a:ln>
             <a:noFill/>
@@ -13026,7 +13421,7 @@
             <a:pPr algn="l">
               <a:defRPr sz="1400" b="0">
                 <a:solidFill>
-                  <a:srgbClr val="AACCEE"/>
+                  <a:srgbClr val="B0E0B0"/>
                 </a:solidFill>
                 <a:latin typeface="Segoe UI"/>
               </a:defRPr>
@@ -13052,7 +13447,7 @@
             <a:avLst/>
           </a:prstGeom>
           <a:solidFill>
-            <a:srgbClr val="007ACC"/>
+            <a:srgbClr val="CD191E"/>
           </a:solidFill>
           <a:ln>
             <a:noFill/>
@@ -13150,13 +13545,13 @@
             <a:pPr algn="l">
               <a:defRPr sz="1400" b="1">
                 <a:solidFill>
-                  <a:srgbClr val="007ACC"/>
+                  <a:srgbClr val="2F9E41"/>
                 </a:solidFill>
                 <a:latin typeface="Segoe UI"/>
               </a:defRPr>
             </a:pPr>
             <a:r>
-              <a:t>Descricao do Trabalho</a:t>
+              <a:t>Descrição do Trabalho</a:t>
             </a:r>
           </a:p>
         </p:txBody>
@@ -13192,7 +13587,7 @@
               </a:defRPr>
             </a:pPr>
             <a:r>
-              <a:t>Framework com ML para ajuste dinamico de parametros de autenticacao baseado em dados contextuais e comportamentais. Resultados: reducao de 27% na FAR e 35% na FRR comparado a metodos estaticos tradicionais. Utiliza biometria multimodal para perfis adaptativos.</a:t>
+              <a:t>Framework com ML para ajuste dinâmico de parâmetros de autenticação baseado em dados contextuais e comportamentais. Resultados: redução de 27% na FAR e 35% na FRR comparado a métodos estáticos tradicionais. Utiliza biometria multimodal para perfis adaptativos.</a:t>
             </a:r>
           </a:p>
         </p:txBody>
@@ -13267,13 +13662,13 @@
             <a:pPr algn="l">
               <a:defRPr sz="1400" b="1">
                 <a:solidFill>
-                  <a:srgbClr val="27AE60"/>
+                  <a:srgbClr val="2F9E41"/>
                 </a:solidFill>
                 <a:latin typeface="Segoe UI"/>
               </a:defRPr>
             </a:pPr>
             <a:r>
-              <a:t>Comparacao com a Proposta</a:t>
+              <a:t>Comparação com a Proposta</a:t>
             </a:r>
           </a:p>
         </p:txBody>
@@ -13309,7 +13704,7 @@
               </a:defRPr>
             </a:pPr>
             <a:r>
-              <a:t>A proposta compartilha o principio de ajuste dinamico, mas implementa ensemble de 3 algoritmos com pesos configuraveis (IF 40%, RF 30%, DL 30%) e regras de decisao escalonadas em 4 niveis (permitir, MFA, MFA+alerta, bloquear). Integra blockchain para registro imutavel de cada decisao.</a:t>
+              <a:t>A proposta compartilha o princípio de ajuste dinâmico, mas implementa ensemble de 3 algoritmos com pesos configuráveis (IF 40%, RF 30%, DL 30%) e regras de decisão escalonadas em 4 níveis (permitir, MFA, MFA+alerta, bloquear). Integra blockchain para registro imutável de cada decisão.</a:t>
             </a:r>
           </a:p>
         </p:txBody>
@@ -13355,7 +13750,7 @@
             <a:avLst/>
           </a:prstGeom>
           <a:solidFill>
-            <a:srgbClr val="0D1B2A"/>
+            <a:srgbClr val="1A6B2A"/>
           </a:solidFill>
           <a:ln>
             <a:noFill/>
@@ -13444,7 +13839,7 @@
             <a:pPr algn="l">
               <a:defRPr sz="1400" b="0">
                 <a:solidFill>
-                  <a:srgbClr val="AACCEE"/>
+                  <a:srgbClr val="B0E0B0"/>
                 </a:solidFill>
                 <a:latin typeface="Segoe UI"/>
               </a:defRPr>
@@ -13470,7 +13865,7 @@
             <a:avLst/>
           </a:prstGeom>
           <a:solidFill>
-            <a:srgbClr val="007ACC"/>
+            <a:srgbClr val="CD191E"/>
           </a:solidFill>
           <a:ln>
             <a:noFill/>
@@ -13568,13 +13963,13 @@
             <a:pPr algn="l">
               <a:defRPr sz="1400" b="1">
                 <a:solidFill>
-                  <a:srgbClr val="007ACC"/>
+                  <a:srgbClr val="2F9E41"/>
                 </a:solidFill>
                 <a:latin typeface="Segoe UI"/>
               </a:defRPr>
             </a:pPr>
             <a:r>
-              <a:t>Descricao do Trabalho</a:t>
+              <a:t>Descrição do Trabalho</a:t>
             </a:r>
           </a:p>
         </p:txBody>
@@ -13610,7 +14005,7 @@
               </a:defRPr>
             </a:pPr>
             <a:r>
-              <a:t>O trabalho da MDPI utiliza pipeline de CNN+LSTM+GRU para autenticacao continua em moveis. O da Springer aplica KNN, RF e LGBM para keystroke dynamics, alcancando EER de 2.67% a 6.61%. Ambos demonstram a eficacia de ensembles e biometria comportamental.</a:t>
+              <a:t>O trabalho da MDPI utiliza pipeline de CNN+LSTM+GRU para autenticação contínua em móveis. O da Springer aplica KNN, RF e LGBM para keystroke dynamics, alcançando EER de 2.67% a 6.61%. Ambos demonstram a eficácia de ensembles e biometria comportamental.</a:t>
             </a:r>
           </a:p>
         </p:txBody>
@@ -13685,13 +14080,13 @@
             <a:pPr algn="l">
               <a:defRPr sz="1400" b="1">
                 <a:solidFill>
-                  <a:srgbClr val="27AE60"/>
+                  <a:srgbClr val="2F9E41"/>
                 </a:solidFill>
                 <a:latin typeface="Segoe UI"/>
               </a:defRPr>
             </a:pPr>
             <a:r>
-              <a:t>Comparacao com a Proposta</a:t>
+              <a:t>Comparação com a Proposta</a:t>
             </a:r>
           </a:p>
         </p:txBody>
@@ -13727,7 +14122,7 @@
               </a:defRPr>
             </a:pPr>
             <a:r>
-              <a:t>O sistema proposto integra dinamica de digitacao como uma das 14 features do ensemble (nao isoladamente), combinando com geolocalizacao, padrao de sessao e contexto. Adiciona explicabilidade SHAP e score persistente em blockchain — aspectos nao abordados nos trabalhos comparados.</a:t>
+              <a:t>O sistema proposto integra dinâmica de digitação como uma das 14 features do ensemble (não isoladamente), combinando com geolocalização, padrão de sessão e contexto. Adiciona explicabilidade SHAP e score persistente em blockchain — aspectos não abordados nos trabalhos comparados.</a:t>
             </a:r>
           </a:p>
         </p:txBody>

</xml_diff>

<commit_message>
Ajustes solicitados pelo profe
</commit_message>
<xml_diff>
--- a/docs/trabalhos-relacionados.pptx
+++ b/docs/trabalhos-relacionados.pptx
@@ -1377,7 +1377,7 @@
           <a:effectLst/>
           <a:extLst>
             <a:ext uri="{91240B29-F687-4f45-9708-019B960494DF}">
-              <a14:hiddenLine xmlns="" xmlns:a14="http://schemas.microsoft.com/office/drawing/2010/main" w="9525" cap="flat">
+              <a14:hiddenLine xmlns:a14="http://schemas.microsoft.com/office/drawing/2010/main" xmlns="" w="9525" cap="flat">
                 <a:solidFill>
                   <a:srgbClr val="3465A4"/>
                 </a:solidFill>
@@ -1387,7 +1387,7 @@
               </a14:hiddenLine>
             </a:ext>
             <a:ext uri="{AF507438-7753-43e0-B8FC-AC1667EBCBE1}">
-              <a14:hiddenEffects xmlns="" xmlns:a14="http://schemas.microsoft.com/office/drawing/2010/main">
+              <a14:hiddenEffects xmlns:a14="http://schemas.microsoft.com/office/drawing/2010/main" xmlns="">
                 <a:effectLst>
                   <a:outerShdw blurRad="63500" dist="38099" dir="2700000" algn="ctr" rotWithShape="0">
                     <a:srgbClr val="000000">
@@ -1442,14 +1442,14 @@
           <a:effectLst/>
           <a:extLst>
             <a:ext uri="{909E8E84-426E-40dd-AFC4-6F175D3DCCD1}">
-              <a14:hiddenFill xmlns="" xmlns:a14="http://schemas.microsoft.com/office/drawing/2010/main">
+              <a14:hiddenFill xmlns:a14="http://schemas.microsoft.com/office/drawing/2010/main" xmlns="">
                 <a:solidFill>
                   <a:srgbClr val="FFFFFF"/>
                 </a:solidFill>
               </a14:hiddenFill>
             </a:ext>
             <a:ext uri="{91240B29-F687-4f45-9708-019B960494DF}">
-              <a14:hiddenLine xmlns="" xmlns:a14="http://schemas.microsoft.com/office/drawing/2010/main" w="9525" cap="flat">
+              <a14:hiddenLine xmlns:a14="http://schemas.microsoft.com/office/drawing/2010/main" xmlns="" w="9525" cap="flat">
                 <a:solidFill>
                   <a:srgbClr val="3465A4"/>
                 </a:solidFill>
@@ -1459,7 +1459,7 @@
               </a14:hiddenLine>
             </a:ext>
             <a:ext uri="{AF507438-7753-43e0-B8FC-AC1667EBCBE1}">
-              <a14:hiddenEffects xmlns="" xmlns:a14="http://schemas.microsoft.com/office/drawing/2010/main">
+              <a14:hiddenEffects xmlns:a14="http://schemas.microsoft.com/office/drawing/2010/main" xmlns="">
                 <a:effectLst>
                   <a:outerShdw blurRad="63500" dist="38099" dir="2700000" algn="ctr" rotWithShape="0">
                     <a:srgbClr val="000000">
@@ -1837,14 +1837,14 @@
           <a:effectLst/>
           <a:extLst>
             <a:ext uri="{909E8E84-426E-40dd-AFC4-6F175D3DCCD1}">
-              <a14:hiddenFill xmlns="" xmlns:a14="http://schemas.microsoft.com/office/drawing/2010/main">
+              <a14:hiddenFill xmlns:a14="http://schemas.microsoft.com/office/drawing/2010/main" xmlns="">
                 <a:solidFill>
                   <a:srgbClr val="FFFFFF"/>
                 </a:solidFill>
               </a14:hiddenFill>
             </a:ext>
             <a:ext uri="{91240B29-F687-4f45-9708-019B960494DF}">
-              <a14:hiddenLine xmlns="" xmlns:a14="http://schemas.microsoft.com/office/drawing/2010/main" w="9525" cap="flat">
+              <a14:hiddenLine xmlns:a14="http://schemas.microsoft.com/office/drawing/2010/main" xmlns="" w="9525" cap="flat">
                 <a:solidFill>
                   <a:srgbClr val="3465A4"/>
                 </a:solidFill>
@@ -1854,7 +1854,7 @@
               </a14:hiddenLine>
             </a:ext>
             <a:ext uri="{AF507438-7753-43e0-B8FC-AC1667EBCBE1}">
-              <a14:hiddenEffects xmlns="" xmlns:a14="http://schemas.microsoft.com/office/drawing/2010/main">
+              <a14:hiddenEffects xmlns:a14="http://schemas.microsoft.com/office/drawing/2010/main" xmlns="">
                 <a:effectLst>
                   <a:outerShdw blurRad="63500" dist="38099" dir="2700000" algn="ctr" rotWithShape="0">
                     <a:schemeClr val="bg2">
@@ -1865,7 +1865,7 @@
               </a14:hiddenEffects>
             </a:ext>
             <a:ext uri="{FAA26D3D-D897-4be2-8F04-BA451C77F1D7}">
-              <ma14:placeholderFlag xmlns="" xmlns:ma14="http://schemas.microsoft.com/office/mac/drawingml/2011/main" val="1"/>
+              <ma14:placeholderFlag xmlns:ma14="http://schemas.microsoft.com/office/mac/drawingml/2011/main" xmlns="" val="1"/>
             </a:ext>
           </a:extLst>
         </p:spPr>
@@ -2158,7 +2158,7 @@
           <a:effectLst/>
           <a:extLst>
             <a:ext uri="{909E8E84-426E-40dd-AFC4-6F175D3DCCD1}">
-              <a14:hiddenFill xmlns="" xmlns:a14="http://schemas.microsoft.com/office/drawing/2010/main">
+              <a14:hiddenFill xmlns:a14="http://schemas.microsoft.com/office/drawing/2010/main" xmlns="">
                 <a:blipFill dpi="0" rotWithShape="0">
                   <a:blip xmlns:r="http://schemas.openxmlformats.org/officeDocument/2006/relationships"/>
                   <a:srcRect/>
@@ -2169,7 +2169,7 @@
               </a14:hiddenFill>
             </a:ext>
             <a:ext uri="{91240B29-F687-4f45-9708-019B960494DF}">
-              <a14:hiddenLine xmlns="" xmlns:a14="http://schemas.microsoft.com/office/drawing/2010/main" w="9525" cap="flat">
+              <a14:hiddenLine xmlns:a14="http://schemas.microsoft.com/office/drawing/2010/main" xmlns="" w="9525" cap="flat">
                 <a:solidFill>
                   <a:srgbClr val="3465A4"/>
                 </a:solidFill>
@@ -2179,7 +2179,7 @@
               </a14:hiddenLine>
             </a:ext>
             <a:ext uri="{AF507438-7753-43e0-B8FC-AC1667EBCBE1}">
-              <a14:hiddenEffects xmlns="" xmlns:a14="http://schemas.microsoft.com/office/drawing/2010/main">
+              <a14:hiddenEffects xmlns:a14="http://schemas.microsoft.com/office/drawing/2010/main" xmlns="">
                 <a:effectLst>
                   <a:outerShdw blurRad="63500" dist="38099" dir="2700000" algn="ctr" rotWithShape="0">
                     <a:srgbClr val="000000">
@@ -2307,14 +2307,14 @@
         <p:spPr>
           <a:extLst>
             <a:ext uri="{909E8E84-426E-40dd-AFC4-6F175D3DCCD1}">
-              <a14:hiddenFill xmlns="" xmlns:a14="http://schemas.microsoft.com/office/drawing/2010/main">
+              <a14:hiddenFill xmlns:a14="http://schemas.microsoft.com/office/drawing/2010/main" xmlns="">
                 <a:solidFill>
                   <a:srgbClr val="FFFFFF"/>
                 </a:solidFill>
               </a14:hiddenFill>
             </a:ext>
             <a:ext uri="{91240B29-F687-4f45-9708-019B960494DF}">
-              <a14:hiddenLine xmlns="" xmlns:a14="http://schemas.microsoft.com/office/drawing/2010/main" w="9525" cap="flat">
+              <a14:hiddenLine xmlns:a14="http://schemas.microsoft.com/office/drawing/2010/main" xmlns="" w="9525" cap="flat">
                 <a:solidFill>
                   <a:srgbClr val="3465A4"/>
                 </a:solidFill>
@@ -2324,7 +2324,7 @@
               </a14:hiddenLine>
             </a:ext>
             <a:ext uri="{AF507438-7753-43e0-B8FC-AC1667EBCBE1}">
-              <a14:hiddenEffects xmlns="" xmlns:a14="http://schemas.microsoft.com/office/drawing/2010/main">
+              <a14:hiddenEffects xmlns:a14="http://schemas.microsoft.com/office/drawing/2010/main" xmlns="">
                 <a:effectLst>
                   <a:outerShdw blurRad="63500" dist="38099" dir="2700000" algn="ctr" rotWithShape="0">
                     <a:schemeClr val="bg2">
@@ -2335,7 +2335,7 @@
               </a14:hiddenEffects>
             </a:ext>
             <a:ext uri="{FAA26D3D-D897-4be2-8F04-BA451C77F1D7}">
-              <ma14:placeholderFlag xmlns="" xmlns:ma14="http://schemas.microsoft.com/office/mac/drawingml/2011/main" val="1"/>
+              <ma14:placeholderFlag xmlns:ma14="http://schemas.microsoft.com/office/mac/drawingml/2011/main" xmlns="" val="1"/>
             </a:ext>
           </a:extLst>
         </p:spPr>
@@ -9709,7 +9709,7 @@
           <a:effectLst/>
           <a:extLst>
             <a:ext uri="{91240B29-F687-4f45-9708-019B960494DF}">
-              <a14:hiddenLine xmlns="" xmlns:a14="http://schemas.microsoft.com/office/drawing/2010/main" w="9525" cap="flat">
+              <a14:hiddenLine xmlns:a14="http://schemas.microsoft.com/office/drawing/2010/main" xmlns="" w="9525" cap="flat">
                 <a:solidFill>
                   <a:srgbClr val="3465A4"/>
                 </a:solidFill>
@@ -9719,7 +9719,7 @@
               </a14:hiddenLine>
             </a:ext>
             <a:ext uri="{AF507438-7753-43e0-B8FC-AC1667EBCBE1}">
-              <a14:hiddenEffects xmlns="" xmlns:a14="http://schemas.microsoft.com/office/drawing/2010/main">
+              <a14:hiddenEffects xmlns:a14="http://schemas.microsoft.com/office/drawing/2010/main" xmlns="">
                 <a:effectLst>
                   <a:outerShdw blurRad="63500" dist="38099" dir="2700000" algn="ctr" rotWithShape="0">
                     <a:srgbClr val="000000">
@@ -9776,14 +9776,14 @@
           <a:effectLst/>
           <a:extLst>
             <a:ext uri="{909E8E84-426E-40dd-AFC4-6F175D3DCCD1}">
-              <a14:hiddenFill xmlns="" xmlns:a14="http://schemas.microsoft.com/office/drawing/2010/main">
+              <a14:hiddenFill xmlns:a14="http://schemas.microsoft.com/office/drawing/2010/main" xmlns="">
                 <a:solidFill>
                   <a:srgbClr val="FFFFFF"/>
                 </a:solidFill>
               </a14:hiddenFill>
             </a:ext>
             <a:ext uri="{91240B29-F687-4f45-9708-019B960494DF}">
-              <a14:hiddenLine xmlns="" xmlns:a14="http://schemas.microsoft.com/office/drawing/2010/main" w="9525" cap="flat">
+              <a14:hiddenLine xmlns:a14="http://schemas.microsoft.com/office/drawing/2010/main" xmlns="" w="9525" cap="flat">
                 <a:solidFill>
                   <a:srgbClr val="3465A4"/>
                 </a:solidFill>
@@ -9793,7 +9793,7 @@
               </a14:hiddenLine>
             </a:ext>
             <a:ext uri="{AF507438-7753-43e0-B8FC-AC1667EBCBE1}">
-              <a14:hiddenEffects xmlns="" xmlns:a14="http://schemas.microsoft.com/office/drawing/2010/main">
+              <a14:hiddenEffects xmlns:a14="http://schemas.microsoft.com/office/drawing/2010/main" xmlns="">
                 <a:effectLst>
                   <a:outerShdw blurRad="63500" dist="38099" dir="2700000" algn="ctr" rotWithShape="0">
                     <a:schemeClr val="bg2">
@@ -9804,7 +9804,7 @@
               </a14:hiddenEffects>
             </a:ext>
             <a:ext uri="{FAA26D3D-D897-4be2-8F04-BA451C77F1D7}">
-              <ma14:placeholderFlag xmlns="" xmlns:ma14="http://schemas.microsoft.com/office/mac/drawingml/2011/main" val="1"/>
+              <ma14:placeholderFlag xmlns:ma14="http://schemas.microsoft.com/office/mac/drawingml/2011/main" xmlns="" val="1"/>
             </a:ext>
           </a:extLst>
         </p:spPr>
@@ -9855,14 +9855,14 @@
           <a:effectLst/>
           <a:extLst>
             <a:ext uri="{909E8E84-426E-40dd-AFC4-6F175D3DCCD1}">
-              <a14:hiddenFill xmlns="" xmlns:a14="http://schemas.microsoft.com/office/drawing/2010/main">
+              <a14:hiddenFill xmlns:a14="http://schemas.microsoft.com/office/drawing/2010/main" xmlns="">
                 <a:solidFill>
                   <a:srgbClr val="FFFFFF"/>
                 </a:solidFill>
               </a14:hiddenFill>
             </a:ext>
             <a:ext uri="{91240B29-F687-4f45-9708-019B960494DF}">
-              <a14:hiddenLine xmlns="" xmlns:a14="http://schemas.microsoft.com/office/drawing/2010/main" w="9525" cap="flat">
+              <a14:hiddenLine xmlns:a14="http://schemas.microsoft.com/office/drawing/2010/main" xmlns="" w="9525" cap="flat">
                 <a:solidFill>
                   <a:srgbClr val="3465A4"/>
                 </a:solidFill>
@@ -9872,7 +9872,7 @@
               </a14:hiddenLine>
             </a:ext>
             <a:ext uri="{AF507438-7753-43e0-B8FC-AC1667EBCBE1}">
-              <a14:hiddenEffects xmlns="" xmlns:a14="http://schemas.microsoft.com/office/drawing/2010/main">
+              <a14:hiddenEffects xmlns:a14="http://schemas.microsoft.com/office/drawing/2010/main" xmlns="">
                 <a:effectLst>
                   <a:outerShdw blurRad="63500" dist="38099" dir="2700000" algn="ctr" rotWithShape="0">
                     <a:schemeClr val="bg2">
@@ -9883,7 +9883,7 @@
               </a14:hiddenEffects>
             </a:ext>
             <a:ext uri="{FAA26D3D-D897-4be2-8F04-BA451C77F1D7}">
-              <ma14:placeholderFlag xmlns="" xmlns:ma14="http://schemas.microsoft.com/office/mac/drawingml/2011/main" val="1"/>
+              <ma14:placeholderFlag xmlns:ma14="http://schemas.microsoft.com/office/mac/drawingml/2011/main" xmlns="" val="1"/>
             </a:ext>
           </a:extLst>
         </p:spPr>
@@ -9963,14 +9963,14 @@
           <a:effectLst/>
           <a:extLst>
             <a:ext uri="{909E8E84-426E-40dd-AFC4-6F175D3DCCD1}">
-              <a14:hiddenFill xmlns="" xmlns:a14="http://schemas.microsoft.com/office/drawing/2010/main">
+              <a14:hiddenFill xmlns:a14="http://schemas.microsoft.com/office/drawing/2010/main" xmlns="">
                 <a:solidFill>
                   <a:srgbClr val="FFFFFF"/>
                 </a:solidFill>
               </a14:hiddenFill>
             </a:ext>
             <a:ext uri="{91240B29-F687-4f45-9708-019B960494DF}">
-              <a14:hiddenLine xmlns="" xmlns:a14="http://schemas.microsoft.com/office/drawing/2010/main" w="9525" cap="flat">
+              <a14:hiddenLine xmlns:a14="http://schemas.microsoft.com/office/drawing/2010/main" xmlns="" w="9525" cap="flat">
                 <a:solidFill>
                   <a:srgbClr val="3465A4"/>
                 </a:solidFill>
@@ -9980,7 +9980,7 @@
               </a14:hiddenLine>
             </a:ext>
             <a:ext uri="{AF507438-7753-43e0-B8FC-AC1667EBCBE1}">
-              <a14:hiddenEffects xmlns="" xmlns:a14="http://schemas.microsoft.com/office/drawing/2010/main">
+              <a14:hiddenEffects xmlns:a14="http://schemas.microsoft.com/office/drawing/2010/main" xmlns="">
                 <a:effectLst>
                   <a:outerShdw blurRad="63500" dist="38099" dir="2700000" algn="ctr" rotWithShape="0">
                     <a:schemeClr val="bg2">
@@ -9991,7 +9991,7 @@
               </a14:hiddenEffects>
             </a:ext>
             <a:ext uri="{FAA26D3D-D897-4be2-8F04-BA451C77F1D7}">
-              <ma14:placeholderFlag xmlns="" xmlns:ma14="http://schemas.microsoft.com/office/mac/drawingml/2011/main" val="1"/>
+              <ma14:placeholderFlag xmlns:ma14="http://schemas.microsoft.com/office/mac/drawingml/2011/main" xmlns="" val="1"/>
             </a:ext>
           </a:extLst>
         </p:spPr>
@@ -10057,14 +10057,14 @@
           <a:effectLst/>
           <a:extLst>
             <a:ext uri="{909E8E84-426E-40dd-AFC4-6F175D3DCCD1}">
-              <a14:hiddenFill xmlns="" xmlns:a14="http://schemas.microsoft.com/office/drawing/2010/main">
+              <a14:hiddenFill xmlns:a14="http://schemas.microsoft.com/office/drawing/2010/main" xmlns="">
                 <a:solidFill>
                   <a:srgbClr val="FFFFFF"/>
                 </a:solidFill>
               </a14:hiddenFill>
             </a:ext>
             <a:ext uri="{91240B29-F687-4f45-9708-019B960494DF}">
-              <a14:hiddenLine xmlns="" xmlns:a14="http://schemas.microsoft.com/office/drawing/2010/main" w="9525" cap="flat">
+              <a14:hiddenLine xmlns:a14="http://schemas.microsoft.com/office/drawing/2010/main" xmlns="" w="9525" cap="flat">
                 <a:solidFill>
                   <a:srgbClr val="3465A4"/>
                 </a:solidFill>
@@ -10074,7 +10074,7 @@
               </a14:hiddenLine>
             </a:ext>
             <a:ext uri="{AF507438-7753-43e0-B8FC-AC1667EBCBE1}">
-              <a14:hiddenEffects xmlns="" xmlns:a14="http://schemas.microsoft.com/office/drawing/2010/main">
+              <a14:hiddenEffects xmlns:a14="http://schemas.microsoft.com/office/drawing/2010/main" xmlns="">
                 <a:effectLst>
                   <a:outerShdw blurRad="63500" dist="38099" dir="2700000" algn="ctr" rotWithShape="0">
                     <a:srgbClr val="000000">
@@ -10452,14 +10452,14 @@
           <a:effectLst/>
           <a:extLst>
             <a:ext uri="{909E8E84-426E-40dd-AFC4-6F175D3DCCD1}">
-              <a14:hiddenFill xmlns="" xmlns:a14="http://schemas.microsoft.com/office/drawing/2010/main">
+              <a14:hiddenFill xmlns:a14="http://schemas.microsoft.com/office/drawing/2010/main" xmlns="">
                 <a:solidFill>
                   <a:srgbClr val="FFFFFF"/>
                 </a:solidFill>
               </a14:hiddenFill>
             </a:ext>
             <a:ext uri="{91240B29-F687-4f45-9708-019B960494DF}">
-              <a14:hiddenLine xmlns="" xmlns:a14="http://schemas.microsoft.com/office/drawing/2010/main" w="9525" cap="flat">
+              <a14:hiddenLine xmlns:a14="http://schemas.microsoft.com/office/drawing/2010/main" xmlns="" w="9525" cap="flat">
                 <a:solidFill>
                   <a:srgbClr val="3465A4"/>
                 </a:solidFill>
@@ -10469,7 +10469,7 @@
               </a14:hiddenLine>
             </a:ext>
             <a:ext uri="{AF507438-7753-43e0-B8FC-AC1667EBCBE1}">
-              <a14:hiddenEffects xmlns="" xmlns:a14="http://schemas.microsoft.com/office/drawing/2010/main">
+              <a14:hiddenEffects xmlns:a14="http://schemas.microsoft.com/office/drawing/2010/main" xmlns="">
                 <a:effectLst>
                   <a:outerShdw blurRad="63500" dist="38099" dir="2700000" algn="ctr" rotWithShape="0">
                     <a:schemeClr val="bg2">
@@ -10480,7 +10480,7 @@
               </a14:hiddenEffects>
             </a:ext>
             <a:ext uri="{FAA26D3D-D897-4be2-8F04-BA451C77F1D7}">
-              <ma14:placeholderFlag xmlns="" xmlns:ma14="http://schemas.microsoft.com/office/mac/drawingml/2011/main" val="1"/>
+              <ma14:placeholderFlag xmlns:ma14="http://schemas.microsoft.com/office/mac/drawingml/2011/main" xmlns="" val="1"/>
             </a:ext>
           </a:extLst>
         </p:spPr>
@@ -11411,14 +11411,14 @@
           <a:effectLst/>
           <a:extLst>
             <a:ext uri="{909E8E84-426E-40dd-AFC4-6F175D3DCCD1}">
-              <a14:hiddenFill xmlns="" xmlns:a14="http://schemas.microsoft.com/office/drawing/2010/main">
+              <a14:hiddenFill xmlns:a14="http://schemas.microsoft.com/office/drawing/2010/main" xmlns="">
                 <a:solidFill>
                   <a:srgbClr val="FFFFFF"/>
                 </a:solidFill>
               </a14:hiddenFill>
             </a:ext>
             <a:ext uri="{91240B29-F687-4f45-9708-019B960494DF}">
-              <a14:hiddenLine xmlns="" xmlns:a14="http://schemas.microsoft.com/office/drawing/2010/main" w="9525" cap="flat">
+              <a14:hiddenLine xmlns:a14="http://schemas.microsoft.com/office/drawing/2010/main" xmlns="" w="9525" cap="flat">
                 <a:solidFill>
                   <a:srgbClr val="3465A4"/>
                 </a:solidFill>
@@ -11428,7 +11428,7 @@
               </a14:hiddenLine>
             </a:ext>
             <a:ext uri="{AF507438-7753-43e0-B8FC-AC1667EBCBE1}">
-              <a14:hiddenEffects xmlns="" xmlns:a14="http://schemas.microsoft.com/office/drawing/2010/main">
+              <a14:hiddenEffects xmlns:a14="http://schemas.microsoft.com/office/drawing/2010/main" xmlns="">
                 <a:effectLst>
                   <a:outerShdw blurRad="63500" dist="38099" dir="2700000" algn="ctr" rotWithShape="0">
                     <a:schemeClr val="bg2">
@@ -11439,7 +11439,7 @@
               </a14:hiddenEffects>
             </a:ext>
             <a:ext uri="{FAA26D3D-D897-4be2-8F04-BA451C77F1D7}">
-              <ma14:placeholderFlag xmlns="" xmlns:ma14="http://schemas.microsoft.com/office/mac/drawingml/2011/main" val="1"/>
+              <ma14:placeholderFlag xmlns:ma14="http://schemas.microsoft.com/office/mac/drawingml/2011/main" xmlns="" val="1"/>
             </a:ext>
           </a:extLst>
         </p:spPr>
@@ -11490,14 +11490,14 @@
           <a:effectLst/>
           <a:extLst>
             <a:ext uri="{909E8E84-426E-40dd-AFC4-6F175D3DCCD1}">
-              <a14:hiddenFill xmlns="" xmlns:a14="http://schemas.microsoft.com/office/drawing/2010/main">
+              <a14:hiddenFill xmlns:a14="http://schemas.microsoft.com/office/drawing/2010/main" xmlns="">
                 <a:solidFill>
                   <a:srgbClr val="FFFFFF"/>
                 </a:solidFill>
               </a14:hiddenFill>
             </a:ext>
             <a:ext uri="{91240B29-F687-4f45-9708-019B960494DF}">
-              <a14:hiddenLine xmlns="" xmlns:a14="http://schemas.microsoft.com/office/drawing/2010/main" w="9525" cap="flat">
+              <a14:hiddenLine xmlns:a14="http://schemas.microsoft.com/office/drawing/2010/main" xmlns="" w="9525" cap="flat">
                 <a:solidFill>
                   <a:srgbClr val="3465A4"/>
                 </a:solidFill>
@@ -11507,7 +11507,7 @@
               </a14:hiddenLine>
             </a:ext>
             <a:ext uri="{AF507438-7753-43e0-B8FC-AC1667EBCBE1}">
-              <a14:hiddenEffects xmlns="" xmlns:a14="http://schemas.microsoft.com/office/drawing/2010/main">
+              <a14:hiddenEffects xmlns:a14="http://schemas.microsoft.com/office/drawing/2010/main" xmlns="">
                 <a:effectLst>
                   <a:outerShdw blurRad="63500" dist="38099" dir="2700000" algn="ctr" rotWithShape="0">
                     <a:schemeClr val="bg2">
@@ -11518,7 +11518,7 @@
               </a14:hiddenEffects>
             </a:ext>
             <a:ext uri="{FAA26D3D-D897-4be2-8F04-BA451C77F1D7}">
-              <ma14:placeholderFlag xmlns="" xmlns:ma14="http://schemas.microsoft.com/office/mac/drawingml/2011/main" val="1"/>
+              <ma14:placeholderFlag xmlns:ma14="http://schemas.microsoft.com/office/mac/drawingml/2011/main" xmlns="" val="1"/>
             </a:ext>
           </a:extLst>
         </p:spPr>
@@ -11611,14 +11611,14 @@
           <a:effectLst/>
           <a:extLst>
             <a:ext uri="{909E8E84-426E-40dd-AFC4-6F175D3DCCD1}">
-              <a14:hiddenFill xmlns="" xmlns:a14="http://schemas.microsoft.com/office/drawing/2010/main">
+              <a14:hiddenFill xmlns:a14="http://schemas.microsoft.com/office/drawing/2010/main" xmlns="">
                 <a:solidFill>
                   <a:srgbClr val="FFFFFF"/>
                 </a:solidFill>
               </a14:hiddenFill>
             </a:ext>
             <a:ext uri="{91240B29-F687-4f45-9708-019B960494DF}">
-              <a14:hiddenLine xmlns="" xmlns:a14="http://schemas.microsoft.com/office/drawing/2010/main" w="9525" cap="flat">
+              <a14:hiddenLine xmlns:a14="http://schemas.microsoft.com/office/drawing/2010/main" xmlns="" w="9525" cap="flat">
                 <a:solidFill>
                   <a:srgbClr val="3465A4"/>
                 </a:solidFill>
@@ -11628,7 +11628,7 @@
               </a14:hiddenLine>
             </a:ext>
             <a:ext uri="{AF507438-7753-43e0-B8FC-AC1667EBCBE1}">
-              <a14:hiddenEffects xmlns="" xmlns:a14="http://schemas.microsoft.com/office/drawing/2010/main">
+              <a14:hiddenEffects xmlns:a14="http://schemas.microsoft.com/office/drawing/2010/main" xmlns="">
                 <a:effectLst>
                   <a:outerShdw blurRad="63500" dist="38099" dir="2700000" algn="ctr" rotWithShape="0">
                     <a:schemeClr val="bg2">
@@ -11639,7 +11639,7 @@
               </a14:hiddenEffects>
             </a:ext>
             <a:ext uri="{FAA26D3D-D897-4be2-8F04-BA451C77F1D7}">
-              <ma14:placeholderFlag xmlns="" xmlns:ma14="http://schemas.microsoft.com/office/mac/drawingml/2011/main" val="1"/>
+              <ma14:placeholderFlag xmlns:ma14="http://schemas.microsoft.com/office/mac/drawingml/2011/main" xmlns="" val="1"/>
             </a:ext>
           </a:extLst>
         </p:spPr>
@@ -11710,14 +11710,14 @@
           <a:effectLst/>
           <a:extLst>
             <a:ext uri="{909E8E84-426E-40dd-AFC4-6F175D3DCCD1}">
-              <a14:hiddenFill xmlns="" xmlns:a14="http://schemas.microsoft.com/office/drawing/2010/main">
+              <a14:hiddenFill xmlns:a14="http://schemas.microsoft.com/office/drawing/2010/main" xmlns="">
                 <a:solidFill>
                   <a:srgbClr val="FFFFFF"/>
                 </a:solidFill>
               </a14:hiddenFill>
             </a:ext>
             <a:ext uri="{91240B29-F687-4f45-9708-019B960494DF}">
-              <a14:hiddenLine xmlns="" xmlns:a14="http://schemas.microsoft.com/office/drawing/2010/main" w="9525" cap="flat">
+              <a14:hiddenLine xmlns:a14="http://schemas.microsoft.com/office/drawing/2010/main" xmlns="" w="9525" cap="flat">
                 <a:solidFill>
                   <a:srgbClr val="3465A4"/>
                 </a:solidFill>
@@ -11727,7 +11727,7 @@
               </a14:hiddenLine>
             </a:ext>
             <a:ext uri="{AF507438-7753-43e0-B8FC-AC1667EBCBE1}">
-              <a14:hiddenEffects xmlns="" xmlns:a14="http://schemas.microsoft.com/office/drawing/2010/main">
+              <a14:hiddenEffects xmlns:a14="http://schemas.microsoft.com/office/drawing/2010/main" xmlns="">
                 <a:effectLst>
                   <a:outerShdw blurRad="63500" dist="38099" dir="2700000" algn="ctr" rotWithShape="0">
                     <a:schemeClr val="bg2">
@@ -11738,7 +11738,7 @@
               </a14:hiddenEffects>
             </a:ext>
             <a:ext uri="{FAA26D3D-D897-4be2-8F04-BA451C77F1D7}">
-              <ma14:placeholderFlag xmlns="" xmlns:ma14="http://schemas.microsoft.com/office/mac/drawingml/2011/main" val="1"/>
+              <ma14:placeholderFlag xmlns:ma14="http://schemas.microsoft.com/office/mac/drawingml/2011/main" xmlns="" val="1"/>
             </a:ext>
           </a:extLst>
         </p:spPr>
@@ -11813,14 +11813,14 @@
           <a:effectLst/>
           <a:extLst>
             <a:ext uri="{909E8E84-426E-40dd-AFC4-6F175D3DCCD1}">
-              <a14:hiddenFill xmlns="" xmlns:a14="http://schemas.microsoft.com/office/drawing/2010/main">
+              <a14:hiddenFill xmlns:a14="http://schemas.microsoft.com/office/drawing/2010/main" xmlns="">
                 <a:solidFill>
                   <a:srgbClr val="FFFFFF"/>
                 </a:solidFill>
               </a14:hiddenFill>
             </a:ext>
             <a:ext uri="{91240B29-F687-4f45-9708-019B960494DF}">
-              <a14:hiddenLine xmlns="" xmlns:a14="http://schemas.microsoft.com/office/drawing/2010/main" w="9525" cap="flat">
+              <a14:hiddenLine xmlns:a14="http://schemas.microsoft.com/office/drawing/2010/main" xmlns="" w="9525" cap="flat">
                 <a:solidFill>
                   <a:srgbClr val="3465A4"/>
                 </a:solidFill>
@@ -11830,7 +11830,7 @@
               </a14:hiddenLine>
             </a:ext>
             <a:ext uri="{AF507438-7753-43e0-B8FC-AC1667EBCBE1}">
-              <a14:hiddenEffects xmlns="" xmlns:a14="http://schemas.microsoft.com/office/drawing/2010/main">
+              <a14:hiddenEffects xmlns:a14="http://schemas.microsoft.com/office/drawing/2010/main" xmlns="">
                 <a:effectLst>
                   <a:outerShdw blurRad="63500" dist="38099" dir="2700000" algn="ctr" rotWithShape="0">
                     <a:schemeClr val="bg2">
@@ -11841,7 +11841,7 @@
               </a14:hiddenEffects>
             </a:ext>
             <a:ext uri="{FAA26D3D-D897-4be2-8F04-BA451C77F1D7}">
-              <ma14:placeholderFlag xmlns="" xmlns:ma14="http://schemas.microsoft.com/office/mac/drawingml/2011/main" val="1"/>
+              <ma14:placeholderFlag xmlns:ma14="http://schemas.microsoft.com/office/mac/drawingml/2011/main" xmlns="" val="1"/>
             </a:ext>
           </a:extLst>
         </p:spPr>
@@ -12490,14 +12490,14 @@
           <a:effectLst/>
           <a:extLst>
             <a:ext uri="{909E8E84-426E-40dd-AFC4-6F175D3DCCD1}">
-              <a14:hiddenFill xmlns="" xmlns:a14="http://schemas.microsoft.com/office/drawing/2010/main">
+              <a14:hiddenFill xmlns:a14="http://schemas.microsoft.com/office/drawing/2010/main" xmlns="">
                 <a:solidFill>
                   <a:srgbClr val="FFFFFF"/>
                 </a:solidFill>
               </a14:hiddenFill>
             </a:ext>
             <a:ext uri="{91240B29-F687-4f45-9708-019B960494DF}">
-              <a14:hiddenLine xmlns="" xmlns:a14="http://schemas.microsoft.com/office/drawing/2010/main" w="9525" cap="flat">
+              <a14:hiddenLine xmlns:a14="http://schemas.microsoft.com/office/drawing/2010/main" xmlns="" w="9525" cap="flat">
                 <a:solidFill>
                   <a:srgbClr val="3465A4"/>
                 </a:solidFill>
@@ -12507,7 +12507,7 @@
               </a14:hiddenLine>
             </a:ext>
             <a:ext uri="{AF507438-7753-43e0-B8FC-AC1667EBCBE1}">
-              <a14:hiddenEffects xmlns="" xmlns:a14="http://schemas.microsoft.com/office/drawing/2010/main">
+              <a14:hiddenEffects xmlns:a14="http://schemas.microsoft.com/office/drawing/2010/main" xmlns="">
                 <a:effectLst>
                   <a:outerShdw blurRad="63500" dist="38099" dir="2700000" algn="ctr" rotWithShape="0">
                     <a:schemeClr val="bg2">
@@ -12518,7 +12518,7 @@
               </a14:hiddenEffects>
             </a:ext>
             <a:ext uri="{FAA26D3D-D897-4be2-8F04-BA451C77F1D7}">
-              <ma14:placeholderFlag xmlns="" xmlns:ma14="http://schemas.microsoft.com/office/mac/drawingml/2011/main" val="1"/>
+              <ma14:placeholderFlag xmlns:ma14="http://schemas.microsoft.com/office/mac/drawingml/2011/main" xmlns="" val="1"/>
             </a:ext>
           </a:extLst>
         </p:spPr>
@@ -12569,14 +12569,14 @@
           <a:effectLst/>
           <a:extLst>
             <a:ext uri="{909E8E84-426E-40dd-AFC4-6F175D3DCCD1}">
-              <a14:hiddenFill xmlns="" xmlns:a14="http://schemas.microsoft.com/office/drawing/2010/main">
+              <a14:hiddenFill xmlns:a14="http://schemas.microsoft.com/office/drawing/2010/main" xmlns="">
                 <a:solidFill>
                   <a:srgbClr val="FFFFFF"/>
                 </a:solidFill>
               </a14:hiddenFill>
             </a:ext>
             <a:ext uri="{91240B29-F687-4f45-9708-019B960494DF}">
-              <a14:hiddenLine xmlns="" xmlns:a14="http://schemas.microsoft.com/office/drawing/2010/main" w="9525" cap="flat">
+              <a14:hiddenLine xmlns:a14="http://schemas.microsoft.com/office/drawing/2010/main" xmlns="" w="9525" cap="flat">
                 <a:solidFill>
                   <a:srgbClr val="3465A4"/>
                 </a:solidFill>
@@ -12586,7 +12586,7 @@
               </a14:hiddenLine>
             </a:ext>
             <a:ext uri="{AF507438-7753-43e0-B8FC-AC1667EBCBE1}">
-              <a14:hiddenEffects xmlns="" xmlns:a14="http://schemas.microsoft.com/office/drawing/2010/main">
+              <a14:hiddenEffects xmlns:a14="http://schemas.microsoft.com/office/drawing/2010/main" xmlns="">
                 <a:effectLst>
                   <a:outerShdw blurRad="63500" dist="38099" dir="2700000" algn="ctr" rotWithShape="0">
                     <a:schemeClr val="bg2">
@@ -12597,7 +12597,7 @@
               </a14:hiddenEffects>
             </a:ext>
             <a:ext uri="{FAA26D3D-D897-4be2-8F04-BA451C77F1D7}">
-              <ma14:placeholderFlag xmlns="" xmlns:ma14="http://schemas.microsoft.com/office/mac/drawingml/2011/main" val="1"/>
+              <ma14:placeholderFlag xmlns:ma14="http://schemas.microsoft.com/office/mac/drawingml/2011/main" xmlns="" val="1"/>
             </a:ext>
           </a:extLst>
         </p:spPr>
@@ -13259,14 +13259,14 @@
           <a:effectLst/>
           <a:extLst>
             <a:ext uri="{909E8E84-426E-40dd-AFC4-6F175D3DCCD1}">
-              <a14:hiddenFill xmlns="" xmlns:a14="http://schemas.microsoft.com/office/drawing/2010/main">
+              <a14:hiddenFill xmlns:a14="http://schemas.microsoft.com/office/drawing/2010/main" xmlns="">
                 <a:solidFill>
                   <a:srgbClr val="FFFFFF"/>
                 </a:solidFill>
               </a14:hiddenFill>
             </a:ext>
             <a:ext uri="{91240B29-F687-4f45-9708-019B960494DF}">
-              <a14:hiddenLine xmlns="" xmlns:a14="http://schemas.microsoft.com/office/drawing/2010/main" w="9525" cap="flat">
+              <a14:hiddenLine xmlns:a14="http://schemas.microsoft.com/office/drawing/2010/main" xmlns="" w="9525" cap="flat">
                 <a:solidFill>
                   <a:srgbClr val="3465A4"/>
                 </a:solidFill>
@@ -13276,7 +13276,7 @@
               </a14:hiddenLine>
             </a:ext>
             <a:ext uri="{AF507438-7753-43e0-B8FC-AC1667EBCBE1}">
-              <a14:hiddenEffects xmlns="" xmlns:a14="http://schemas.microsoft.com/office/drawing/2010/main">
+              <a14:hiddenEffects xmlns:a14="http://schemas.microsoft.com/office/drawing/2010/main" xmlns="">
                 <a:effectLst>
                   <a:outerShdw blurRad="63500" dist="38099" dir="2700000" algn="ctr" rotWithShape="0">
                     <a:srgbClr val="000000">
@@ -13633,14 +13633,14 @@
           <a:effectLst/>
           <a:extLst>
             <a:ext uri="{909E8E84-426E-40dd-AFC4-6F175D3DCCD1}">
-              <a14:hiddenFill xmlns="" xmlns:a14="http://schemas.microsoft.com/office/drawing/2010/main">
+              <a14:hiddenFill xmlns:a14="http://schemas.microsoft.com/office/drawing/2010/main" xmlns="">
                 <a:solidFill>
                   <a:srgbClr val="FFFFFF"/>
                 </a:solidFill>
               </a14:hiddenFill>
             </a:ext>
             <a:ext uri="{91240B29-F687-4f45-9708-019B960494DF}">
-              <a14:hiddenLine xmlns="" xmlns:a14="http://schemas.microsoft.com/office/drawing/2010/main" w="9525" cap="flat">
+              <a14:hiddenLine xmlns:a14="http://schemas.microsoft.com/office/drawing/2010/main" xmlns="" w="9525" cap="flat">
                 <a:solidFill>
                   <a:srgbClr val="3465A4"/>
                 </a:solidFill>
@@ -13650,7 +13650,7 @@
               </a14:hiddenLine>
             </a:ext>
             <a:ext uri="{AF507438-7753-43e0-B8FC-AC1667EBCBE1}">
-              <a14:hiddenEffects xmlns="" xmlns:a14="http://schemas.microsoft.com/office/drawing/2010/main">
+              <a14:hiddenEffects xmlns:a14="http://schemas.microsoft.com/office/drawing/2010/main" xmlns="">
                 <a:effectLst>
                   <a:outerShdw blurRad="63500" dist="38099" dir="2700000" algn="ctr" rotWithShape="0">
                     <a:srgbClr val="000000">
@@ -14255,7 +14255,7 @@
                         <a:buNone/>
                       </a:pPr>
                       <a:r>
-                        <a:rPr lang="pt-BR" sz="850" b="1">
+                        <a:rPr lang="pt-BR" sz="850" b="1" dirty="0">
                           <a:solidFill>
                             <a:srgbClr val="FFFFFF"/>
                           </a:solidFill>
@@ -15950,7 +15950,7 @@
                         <a:buNone/>
                       </a:pPr>
                       <a:r>
-                        <a:rPr lang="pt-BR" sz="780" b="0">
+                        <a:rPr lang="pt-BR" sz="780" b="0" dirty="0">
                           <a:solidFill>
                             <a:srgbClr val="333333"/>
                           </a:solidFill>
@@ -16057,7 +16057,13 @@
           <p:cNvGraphicFramePr>
             <a:graphicFrameLocks noGrp="1"/>
           </p:cNvGraphicFramePr>
-          <p:nvPr/>
+          <p:nvPr>
+            <p:extLst>
+              <p:ext uri="{D42A27DB-BD31-4B8C-83A1-F6EECF244321}">
+                <p14:modId xmlns:p14="http://schemas.microsoft.com/office/powerpoint/2010/main" val="3397713173"/>
+              </p:ext>
+            </p:extLst>
+          </p:nvPr>
         </p:nvGraphicFramePr>
         <p:xfrm>
           <a:off x="179388" y="1430000"/>
@@ -16198,10 +16204,13 @@
                         <a:buNone/>
                       </a:pPr>
                       <a:r>
-                        <a:rPr lang="pt-BR" sz="750" b="1">
+                        <a:rPr lang="pt-BR" sz="750" b="1" dirty="0">
                           <a:solidFill>
                             <a:srgbClr val="FFFFFF"/>
                           </a:solidFill>
+                          <a:highlight>
+                            <a:srgbClr val="FFFF00"/>
+                          </a:highlight>
                           <a:latin typeface="Titillium Web"/>
                         </a:rPr>
                         <a:t>RBA</a:t>
@@ -17504,7 +17513,7 @@
                         <a:buNone/>
                       </a:pPr>
                       <a:r>
-                        <a:rPr lang="pt-BR" sz="1300" b="1">
+                        <a:rPr lang="pt-BR" sz="1300" b="1" dirty="0">
                           <a:solidFill>
                             <a:srgbClr val="E0892E"/>
                           </a:solidFill>
@@ -18112,24 +18121,12 @@
               </a:spcAft>
               <a:buNone/>
             </a:pPr>
-            <a:r>
-              <a:rPr lang="pt-BR" sz="1000" b="1" dirty="0">
-                <a:solidFill>
-                  <a:srgbClr val="00CC99"/>
-                </a:solidFill>
-                <a:latin typeface="Titillium Web"/>
-              </a:rPr>
-              <a:t>•  </a:t>
-            </a:r>
-            <a:r>
-              <a:rPr lang="pt-BR" sz="980" b="0" dirty="0">
-                <a:solidFill>
-                  <a:srgbClr val="333333"/>
-                </a:solidFill>
-                <a:latin typeface="Titillium Web"/>
-              </a:rPr>
-              <a:t>STRAGAPEDE, G. et al. TypeFormer: Transformers for Mobile Keystroke Biometrics. Neural Computing and Applications, v. 36, 2024.</a:t>
-            </a:r>
+            <a:endParaRPr lang="pt-BR" sz="980" b="0" dirty="0">
+              <a:solidFill>
+                <a:srgbClr val="333333"/>
+              </a:solidFill>
+              <a:latin typeface="Titillium Web"/>
+            </a:endParaRPr>
           </a:p>
           <a:p>
             <a:pPr algn="l">
@@ -18154,7 +18151,7 @@
                 </a:solidFill>
                 <a:latin typeface="Titillium Web"/>
               </a:rPr>
-              <a:t>WIEFLING, S. et al. Pump Up Password Security! ... Risk-Based Authentication. ACM TOPS, v. 26, 2023.</a:t>
+              <a:t>STRAGAPEDE, G. et al. TypeFormer: Transformers for Mobile Keystroke Biometrics. Neural Computing and Applications, v. 36, 2024.</a:t>
             </a:r>
           </a:p>
           <a:p>
@@ -18164,24 +18161,12 @@
               </a:spcAft>
               <a:buNone/>
             </a:pPr>
-            <a:r>
-              <a:rPr lang="pt-BR" sz="1000" b="1" dirty="0">
-                <a:solidFill>
-                  <a:srgbClr val="00CC99"/>
-                </a:solidFill>
-                <a:latin typeface="Titillium Web"/>
-              </a:rPr>
-              <a:t>•  </a:t>
-            </a:r>
-            <a:r>
-              <a:rPr lang="pt-BR" sz="980" b="0" dirty="0">
-                <a:solidFill>
-                  <a:srgbClr val="333333"/>
-                </a:solidFill>
-                <a:latin typeface="Titillium Web"/>
-              </a:rPr>
-              <a:t>WIEFLING, S.; DÜRMUTH, M.; LO IACONO, L. What's in Score for Website Users ... RBA Characteristics. FC, 2021.</a:t>
-            </a:r>
+            <a:endParaRPr lang="pt-BR" sz="980" b="0" dirty="0">
+              <a:solidFill>
+                <a:srgbClr val="333333"/>
+              </a:solidFill>
+              <a:latin typeface="Titillium Web"/>
+            </a:endParaRPr>
           </a:p>
           <a:p>
             <a:pPr algn="l">
@@ -18206,7 +18191,7 @@
                 </a:solidFill>
                 <a:latin typeface="Titillium Web"/>
               </a:rPr>
-              <a:t>ISMAIL, M. G. et al. Outlier Detection for Keystroke Biometric User Authentication. PeerJ CS, 2024.</a:t>
+              <a:t>WIEFLING, S. et al. Pump Up Password Security! ... Risk-Based Authentication. ACM TOPS, v. 26, 2023.</a:t>
             </a:r>
           </a:p>
           <a:p>
@@ -18216,24 +18201,12 @@
               </a:spcAft>
               <a:buNone/>
             </a:pPr>
-            <a:r>
-              <a:rPr lang="pt-BR" sz="1000" b="1" dirty="0">
-                <a:solidFill>
-                  <a:srgbClr val="00CC99"/>
-                </a:solidFill>
-                <a:latin typeface="Titillium Web"/>
-              </a:rPr>
-              <a:t>•  </a:t>
-            </a:r>
-            <a:r>
-              <a:rPr lang="pt-BR" sz="980" b="0" dirty="0">
-                <a:solidFill>
-                  <a:srgbClr val="333333"/>
-                </a:solidFill>
-                <a:latin typeface="Titillium Web"/>
-              </a:rPr>
-              <a:t>CAPUANO, N. et al. Explainable AI in CyberSecurity: A Survey. IEEE Access, v. 10, 2022.</a:t>
-            </a:r>
+            <a:endParaRPr lang="pt-BR" sz="980" b="0" dirty="0">
+              <a:solidFill>
+                <a:srgbClr val="333333"/>
+              </a:solidFill>
+              <a:latin typeface="Titillium Web"/>
+            </a:endParaRPr>
           </a:p>
           <a:p>
             <a:pPr algn="l">
@@ -18258,7 +18231,7 @@
                 </a:solidFill>
                 <a:latin typeface="Titillium Web"/>
               </a:rPr>
-              <a:t>STYLIOS, I. et al. Behavioral Biometrics &amp; Continuous Authentication: A Survey. Information Fusion, v. 66, 2021.</a:t>
+              <a:t>WIEFLING, S.; DÜRMUTH, M.; LO IACONO, L. What's in Score for Website Users ... RBA Characteristics. FC, 2021.</a:t>
             </a:r>
           </a:p>
           <a:p>
@@ -18268,24 +18241,12 @@
               </a:spcAft>
               <a:buNone/>
             </a:pPr>
-            <a:r>
-              <a:rPr lang="pt-BR" sz="1000" b="1" dirty="0">
-                <a:solidFill>
-                  <a:srgbClr val="00CC99"/>
-                </a:solidFill>
-                <a:latin typeface="Titillium Web"/>
-              </a:rPr>
-              <a:t>•  </a:t>
-            </a:r>
-            <a:r>
-              <a:rPr lang="pt-BR" sz="980" b="0" dirty="0">
-                <a:solidFill>
-                  <a:srgbClr val="333333"/>
-                </a:solidFill>
-                <a:latin typeface="Titillium Web"/>
-              </a:rPr>
-              <a:t>ABUHAMAD, M. et al. Sensor-Based Continuous Authentication: A Survey. IEEE IoT Journal, v. 8, 2021.</a:t>
-            </a:r>
+            <a:endParaRPr lang="pt-BR" sz="980" b="0" dirty="0">
+              <a:solidFill>
+                <a:srgbClr val="333333"/>
+              </a:solidFill>
+              <a:latin typeface="Titillium Web"/>
+            </a:endParaRPr>
           </a:p>
           <a:p>
             <a:pPr algn="l">
@@ -18310,7 +18271,7 @@
                 </a:solidFill>
                 <a:latin typeface="Titillium Web"/>
               </a:rPr>
-              <a:t>ROSE, S. et al. Zero Trust Architecture. NIST SP 800-207, 2020.</a:t>
+              <a:t>ISMAIL, M. G. et al. Outlier Detection for Keystroke Biometric User Authentication. PeerJ CS, 2024.</a:t>
             </a:r>
           </a:p>
           <a:p>
@@ -18320,15 +18281,12 @@
               </a:spcAft>
               <a:buNone/>
             </a:pPr>
-            <a:r>
-              <a:rPr lang="pt-BR" sz="1200" b="1" dirty="0">
-                <a:solidFill>
-                  <a:srgbClr val="2D2DB9"/>
-                </a:solidFill>
-                <a:latin typeface="Titillium Web"/>
-              </a:rPr>
-              <a:t>Bases seminais e indústria</a:t>
-            </a:r>
+            <a:endParaRPr lang="pt-BR" sz="980" b="0" dirty="0">
+              <a:solidFill>
+                <a:srgbClr val="333333"/>
+              </a:solidFill>
+              <a:latin typeface="Titillium Web"/>
+            </a:endParaRPr>
           </a:p>
           <a:p>
             <a:pPr algn="l">
@@ -18353,8 +18311,199 @@
                 </a:solidFill>
                 <a:latin typeface="Titillium Web"/>
               </a:rPr>
+              <a:t>CAPUANO, N. et al. Explainable AI in CyberSecurity: A Survey. IEEE Access, v. 10, 2022.</a:t>
+            </a:r>
+          </a:p>
+          <a:p>
+            <a:pPr algn="l">
+              <a:spcAft>
+                <a:spcPts val="200"/>
+              </a:spcAft>
+              <a:buNone/>
+            </a:pPr>
+            <a:endParaRPr lang="pt-BR" sz="980" b="0" dirty="0">
+              <a:solidFill>
+                <a:srgbClr val="333333"/>
+              </a:solidFill>
+              <a:latin typeface="Titillium Web"/>
+            </a:endParaRPr>
+          </a:p>
+          <a:p>
+            <a:pPr algn="l">
+              <a:spcAft>
+                <a:spcPts val="200"/>
+              </a:spcAft>
+              <a:buNone/>
+            </a:pPr>
+            <a:r>
+              <a:rPr lang="pt-BR" sz="1000" b="1" dirty="0">
+                <a:solidFill>
+                  <a:srgbClr val="00CC99"/>
+                </a:solidFill>
+                <a:latin typeface="Titillium Web"/>
+              </a:rPr>
+              <a:t>•  </a:t>
+            </a:r>
+            <a:r>
+              <a:rPr lang="pt-BR" sz="980" b="0" dirty="0">
+                <a:solidFill>
+                  <a:srgbClr val="333333"/>
+                </a:solidFill>
+                <a:latin typeface="Titillium Web"/>
+              </a:rPr>
+              <a:t>STYLIOS, I. et al. Behavioral Biometrics &amp; Continuous Authentication: A Survey. Information Fusion, v. 66, 2021.</a:t>
+            </a:r>
+          </a:p>
+          <a:p>
+            <a:pPr algn="l">
+              <a:spcAft>
+                <a:spcPts val="200"/>
+              </a:spcAft>
+              <a:buNone/>
+            </a:pPr>
+            <a:endParaRPr lang="pt-BR" sz="980" b="0" dirty="0">
+              <a:solidFill>
+                <a:srgbClr val="333333"/>
+              </a:solidFill>
+              <a:latin typeface="Titillium Web"/>
+            </a:endParaRPr>
+          </a:p>
+          <a:p>
+            <a:pPr algn="l">
+              <a:spcAft>
+                <a:spcPts val="200"/>
+              </a:spcAft>
+              <a:buNone/>
+            </a:pPr>
+            <a:r>
+              <a:rPr lang="pt-BR" sz="1000" b="1" dirty="0">
+                <a:solidFill>
+                  <a:srgbClr val="00CC99"/>
+                </a:solidFill>
+                <a:latin typeface="Titillium Web"/>
+              </a:rPr>
+              <a:t>•  </a:t>
+            </a:r>
+            <a:r>
+              <a:rPr lang="pt-BR" sz="980" b="0" dirty="0">
+                <a:solidFill>
+                  <a:srgbClr val="333333"/>
+                </a:solidFill>
+                <a:latin typeface="Titillium Web"/>
+              </a:rPr>
+              <a:t>ABUHAMAD, M. et al. Sensor-Based Continuous Authentication: A Survey. IEEE IoT Journal, v. 8, 2021.</a:t>
+            </a:r>
+          </a:p>
+          <a:p>
+            <a:pPr algn="l">
+              <a:spcAft>
+                <a:spcPts val="200"/>
+              </a:spcAft>
+              <a:buNone/>
+            </a:pPr>
+            <a:endParaRPr lang="pt-BR" sz="980" b="0" dirty="0">
+              <a:solidFill>
+                <a:srgbClr val="333333"/>
+              </a:solidFill>
+              <a:latin typeface="Titillium Web"/>
+            </a:endParaRPr>
+          </a:p>
+          <a:p>
+            <a:pPr algn="l">
+              <a:spcAft>
+                <a:spcPts val="200"/>
+              </a:spcAft>
+              <a:buNone/>
+            </a:pPr>
+            <a:r>
+              <a:rPr lang="pt-BR" sz="1000" b="1" dirty="0">
+                <a:solidFill>
+                  <a:srgbClr val="00CC99"/>
+                </a:solidFill>
+                <a:latin typeface="Titillium Web"/>
+              </a:rPr>
+              <a:t>•  </a:t>
+            </a:r>
+            <a:r>
+              <a:rPr lang="pt-BR" sz="980" b="0" dirty="0">
+                <a:solidFill>
+                  <a:srgbClr val="333333"/>
+                </a:solidFill>
+                <a:latin typeface="Titillium Web"/>
+              </a:rPr>
+              <a:t>ROSE, S. et al. Zero Trust Architecture. NIST SP 800-207, 2020.</a:t>
+            </a:r>
+          </a:p>
+          <a:p>
+            <a:pPr algn="l">
+              <a:spcAft>
+                <a:spcPts val="200"/>
+              </a:spcAft>
+              <a:buNone/>
+            </a:pPr>
+            <a:endParaRPr lang="pt-BR" sz="1200" b="1" dirty="0">
+              <a:solidFill>
+                <a:srgbClr val="2D2DB9"/>
+              </a:solidFill>
+              <a:latin typeface="Titillium Web"/>
+            </a:endParaRPr>
+          </a:p>
+          <a:p>
+            <a:pPr algn="l">
+              <a:spcAft>
+                <a:spcPts val="200"/>
+              </a:spcAft>
+              <a:buNone/>
+            </a:pPr>
+            <a:r>
+              <a:rPr lang="pt-BR" sz="1200" b="1" dirty="0">
+                <a:solidFill>
+                  <a:srgbClr val="2D2DB9"/>
+                </a:solidFill>
+                <a:latin typeface="Titillium Web"/>
+              </a:rPr>
+              <a:t>Bases seminais e indústria</a:t>
+            </a:r>
+          </a:p>
+          <a:p>
+            <a:pPr algn="l">
+              <a:spcAft>
+                <a:spcPts val="200"/>
+              </a:spcAft>
+              <a:buNone/>
+            </a:pPr>
+            <a:r>
+              <a:rPr lang="pt-BR" sz="1000" b="1" dirty="0">
+                <a:solidFill>
+                  <a:srgbClr val="00CC99"/>
+                </a:solidFill>
+                <a:latin typeface="Titillium Web"/>
+              </a:rPr>
+              <a:t>•  </a:t>
+            </a:r>
+            <a:r>
+              <a:rPr lang="pt-BR" sz="980" b="0" dirty="0">
+                <a:solidFill>
+                  <a:srgbClr val="333333"/>
+                </a:solidFill>
+                <a:latin typeface="Titillium Web"/>
+              </a:rPr>
               <a:t>KILLOURHY &amp; MAXION (DSN, 2009); FRANK et al. — Touchalytics (IEEE TIFS, 2013); LIU, TING &amp; ZHOU — Isolation Forest (ICDM, 2008); LUNDBERG &amp; LEE — SHAP (NeurIPS, 2017).</a:t>
             </a:r>
+          </a:p>
+          <a:p>
+            <a:pPr algn="l">
+              <a:spcAft>
+                <a:spcPts val="200"/>
+              </a:spcAft>
+              <a:buNone/>
+            </a:pPr>
+            <a:endParaRPr lang="pt-BR" sz="980" b="0" dirty="0">
+              <a:solidFill>
+                <a:srgbClr val="333333"/>
+              </a:solidFill>
+              <a:latin typeface="Titillium Web"/>
+            </a:endParaRPr>
           </a:p>
           <a:p>
             <a:pPr algn="l">
@@ -18438,14 +18587,14 @@
           <a:effectLst/>
           <a:extLst>
             <a:ext uri="{909E8E84-426E-40dd-AFC4-6F175D3DCCD1}">
-              <a14:hiddenFill xmlns="" xmlns:a14="http://schemas.microsoft.com/office/drawing/2010/main">
+              <a14:hiddenFill xmlns:a14="http://schemas.microsoft.com/office/drawing/2010/main" xmlns="">
                 <a:solidFill>
                   <a:srgbClr val="FFFFFF"/>
                 </a:solidFill>
               </a14:hiddenFill>
             </a:ext>
             <a:ext uri="{91240B29-F687-4f45-9708-019B960494DF}">
-              <a14:hiddenLine xmlns="" xmlns:a14="http://schemas.microsoft.com/office/drawing/2010/main" w="9525" cap="flat">
+              <a14:hiddenLine xmlns:a14="http://schemas.microsoft.com/office/drawing/2010/main" xmlns="" w="9525" cap="flat">
                 <a:solidFill>
                   <a:srgbClr val="3465A4"/>
                 </a:solidFill>
@@ -18455,7 +18604,7 @@
               </a14:hiddenLine>
             </a:ext>
             <a:ext uri="{AF507438-7753-43e0-B8FC-AC1667EBCBE1}">
-              <a14:hiddenEffects xmlns="" xmlns:a14="http://schemas.microsoft.com/office/drawing/2010/main">
+              <a14:hiddenEffects xmlns:a14="http://schemas.microsoft.com/office/drawing/2010/main" xmlns="">
                 <a:effectLst>
                   <a:outerShdw blurRad="63500" dist="38099" dir="2700000" algn="ctr" rotWithShape="0">
                     <a:srgbClr val="000000">
@@ -18812,14 +18961,14 @@
           <a:effectLst/>
           <a:extLst>
             <a:ext uri="{909E8E84-426E-40dd-AFC4-6F175D3DCCD1}">
-              <a14:hiddenFill xmlns="" xmlns:a14="http://schemas.microsoft.com/office/drawing/2010/main">
+              <a14:hiddenFill xmlns:a14="http://schemas.microsoft.com/office/drawing/2010/main" xmlns="">
                 <a:solidFill>
                   <a:srgbClr val="FFFFFF"/>
                 </a:solidFill>
               </a14:hiddenFill>
             </a:ext>
             <a:ext uri="{91240B29-F687-4f45-9708-019B960494DF}">
-              <a14:hiddenLine xmlns="" xmlns:a14="http://schemas.microsoft.com/office/drawing/2010/main" w="9525" cap="flat">
+              <a14:hiddenLine xmlns:a14="http://schemas.microsoft.com/office/drawing/2010/main" xmlns="" w="9525" cap="flat">
                 <a:solidFill>
                   <a:srgbClr val="3465A4"/>
                 </a:solidFill>
@@ -18829,7 +18978,7 @@
               </a14:hiddenLine>
             </a:ext>
             <a:ext uri="{AF507438-7753-43e0-B8FC-AC1667EBCBE1}">
-              <a14:hiddenEffects xmlns="" xmlns:a14="http://schemas.microsoft.com/office/drawing/2010/main">
+              <a14:hiddenEffects xmlns:a14="http://schemas.microsoft.com/office/drawing/2010/main" xmlns="">
                 <a:effectLst>
                   <a:outerShdw blurRad="63500" dist="38099" dir="2700000" algn="ctr" rotWithShape="0">
                     <a:srgbClr val="000000">
@@ -23734,7 +23883,7 @@
         <a:effectLst/>
         <a:extLst>
           <a:ext uri="{AF507438-7753-43e0-B8FC-AC1667EBCBE1}">
-            <a14:hiddenEffects xmlns="" xmlns:a14="http://schemas.microsoft.com/office/drawing/2010/main">
+            <a14:hiddenEffects xmlns:a14="http://schemas.microsoft.com/office/drawing/2010/main" xmlns="">
               <a:effectLst>
                 <a:outerShdw blurRad="63500" dist="38099" dir="2700000" algn="ctr" rotWithShape="0">
                   <a:schemeClr val="bg2">
@@ -23810,7 +23959,7 @@
         <a:effectLst/>
         <a:extLst>
           <a:ext uri="{AF507438-7753-43e0-B8FC-AC1667EBCBE1}">
-            <a14:hiddenEffects xmlns="" xmlns:a14="http://schemas.microsoft.com/office/drawing/2010/main">
+            <a14:hiddenEffects xmlns:a14="http://schemas.microsoft.com/office/drawing/2010/main" xmlns="">
               <a:effectLst>
                 <a:outerShdw blurRad="63500" dist="38099" dir="2700000" algn="ctr" rotWithShape="0">
                   <a:schemeClr val="bg2">
@@ -24396,7 +24545,7 @@
         <a:effectLst/>
         <a:extLst>
           <a:ext uri="{AF507438-7753-43e0-B8FC-AC1667EBCBE1}">
-            <a14:hiddenEffects xmlns="" xmlns:a14="http://schemas.microsoft.com/office/drawing/2010/main">
+            <a14:hiddenEffects xmlns:a14="http://schemas.microsoft.com/office/drawing/2010/main" xmlns="">
               <a:effectLst>
                 <a:outerShdw blurRad="63500" dist="38099" dir="2700000" algn="ctr" rotWithShape="0">
                   <a:schemeClr val="bg2">
@@ -24472,7 +24621,7 @@
         <a:effectLst/>
         <a:extLst>
           <a:ext uri="{AF507438-7753-43e0-B8FC-AC1667EBCBE1}">
-            <a14:hiddenEffects xmlns="" xmlns:a14="http://schemas.microsoft.com/office/drawing/2010/main">
+            <a14:hiddenEffects xmlns:a14="http://schemas.microsoft.com/office/drawing/2010/main" xmlns="">
               <a:effectLst>
                 <a:outerShdw blurRad="63500" dist="38099" dir="2700000" algn="ctr" rotWithShape="0">
                   <a:schemeClr val="bg2">
@@ -25058,7 +25207,7 @@
         <a:effectLst/>
         <a:extLst>
           <a:ext uri="{AF507438-7753-43e0-B8FC-AC1667EBCBE1}">
-            <a14:hiddenEffects xmlns="" xmlns:a14="http://schemas.microsoft.com/office/drawing/2010/main">
+            <a14:hiddenEffects xmlns:a14="http://schemas.microsoft.com/office/drawing/2010/main" xmlns="">
               <a:effectLst>
                 <a:outerShdw blurRad="63500" dist="38099" dir="2700000" algn="ctr" rotWithShape="0">
                   <a:schemeClr val="bg2">
@@ -25134,7 +25283,7 @@
         <a:effectLst/>
         <a:extLst>
           <a:ext uri="{AF507438-7753-43e0-B8FC-AC1667EBCBE1}">
-            <a14:hiddenEffects xmlns="" xmlns:a14="http://schemas.microsoft.com/office/drawing/2010/main">
+            <a14:hiddenEffects xmlns:a14="http://schemas.microsoft.com/office/drawing/2010/main" xmlns="">
               <a:effectLst>
                 <a:outerShdw blurRad="63500" dist="38099" dir="2700000" algn="ctr" rotWithShape="0">
                   <a:schemeClr val="bg2">

</xml_diff>